<commit_message>
Revise alternative asset diversification documentation for clarity and detail
- Updated the analysis of alternative assets (ALT) to emphasize their low correlation with stocks and negative correlation with bonds and cash, highlighting their role in reducing portfolio volatility.
- Enhanced the explanation of the benefits of incorporating ALT into high equity exposure portfolios, focusing on the diversification effect rather than relying on inverse hedging during stock downturns.
- Added performance metrics for ALT and equity to illustrate the superior risk-adjusted returns of ALT during the analyzed period.
</commit_message>
<xml_diff>
--- a/docs/量化策略对比汇报v2.pptx
+++ b/docs/量化策略对比汇报v2.pptx
@@ -4832,31 +4832,6 @@
       </p:sp>
       <p:sp>
         <p:nvSpPr>
-          <p:cNvPr id="27" name="Shape 24"/>
-          <p:cNvSpPr/>
-          <p:nvPr/>
-        </p:nvSpPr>
-        <p:spPr>
-          <a:xfrm>
-            <a:off x="320040" y="4485132"/>
-            <a:ext cx="1828800" cy="274320"/>
-          </a:xfrm>
-          <a:prstGeom prst="rect">
-            <a:avLst/>
-          </a:prstGeom>
-          <a:solidFill>
-            <a:srgbClr val="FEF0E3"/>
-          </a:solidFill>
-          <a:ln w="12700">
-            <a:solidFill>
-              <a:srgbClr val="F47920"/>
-            </a:solidFill>
-            <a:prstDash val="solid"/>
-          </a:ln>
-        </p:spPr>
-      </p:sp>
-      <p:sp>
-        <p:nvSpPr>
           <p:cNvPr id="28" name="Text 25"/>
           <p:cNvSpPr/>
           <p:nvPr/>
@@ -4878,17 +4853,6 @@
             <a:pPr marL="0" indent="0" algn="ctr">
               <a:buNone/>
             </a:pPr>
-            <a:r>
-              <a:rPr lang="en-US" sz="1000" b="1" dirty="0">
-                <a:solidFill>
-                  <a:srgbClr val="1E3A5F"/>
-                </a:solidFill>
-                <a:latin typeface="Calibri" pitchFamily="34" charset="0"/>
-                <a:ea typeface="Calibri" pitchFamily="34" charset="-122"/>
-                <a:cs typeface="Calibri" pitchFamily="34" charset="-120"/>
-              </a:rPr>
-              <a:t>产品池</a:t>
-            </a:r>
             <a:endParaRPr lang="en-US" sz="1000" dirty="0"/>
           </a:p>
         </p:txBody>
@@ -4916,45 +4880,9 @@
             <a:pPr marL="0" indent="0" algn="ctr">
               <a:buNone/>
             </a:pPr>
-            <a:r>
-              <a:rPr lang="en-US" sz="1100" dirty="0">
-                <a:solidFill>
-                  <a:srgbClr val="F47920"/>
-                </a:solidFill>
-                <a:latin typeface="Calibri" pitchFamily="34" charset="0"/>
-                <a:ea typeface="Calibri" pitchFamily="34" charset="-122"/>
-                <a:cs typeface="Calibri" pitchFamily="34" charset="-120"/>
-              </a:rPr>
-              <a:t>▶</a:t>
-            </a:r>
             <a:endParaRPr lang="en-US" sz="1100" dirty="0"/>
           </a:p>
         </p:txBody>
-      </p:sp>
-      <p:sp>
-        <p:nvSpPr>
-          <p:cNvPr id="30" name="Shape 27"/>
-          <p:cNvSpPr/>
-          <p:nvPr/>
-        </p:nvSpPr>
-        <p:spPr>
-          <a:xfrm>
-            <a:off x="2468880" y="4485132"/>
-            <a:ext cx="1828800" cy="274320"/>
-          </a:xfrm>
-          <a:prstGeom prst="rect">
-            <a:avLst/>
-          </a:prstGeom>
-          <a:solidFill>
-            <a:srgbClr val="FEF0E3"/>
-          </a:solidFill>
-          <a:ln w="12700">
-            <a:solidFill>
-              <a:srgbClr val="F47920"/>
-            </a:solidFill>
-            <a:prstDash val="solid"/>
-          </a:ln>
-        </p:spPr>
       </p:sp>
       <p:sp>
         <p:nvSpPr>
@@ -4979,17 +4907,6 @@
             <a:pPr marL="0" indent="0" algn="ctr">
               <a:buNone/>
             </a:pPr>
-            <a:r>
-              <a:rPr lang="en-US" sz="1000" b="1" dirty="0">
-                <a:solidFill>
-                  <a:srgbClr val="1E3A5F"/>
-                </a:solidFill>
-                <a:latin typeface="Calibri" pitchFamily="34" charset="0"/>
-                <a:ea typeface="Calibri" pitchFamily="34" charset="-122"/>
-                <a:cs typeface="Calibri" pitchFamily="34" charset="-120"/>
-              </a:rPr>
-              <a:t>四大类资产</a:t>
-            </a:r>
             <a:endParaRPr lang="en-US" sz="1000" dirty="0"/>
           </a:p>
         </p:txBody>
@@ -5017,45 +4934,9 @@
             <a:pPr marL="0" indent="0" algn="ctr">
               <a:buNone/>
             </a:pPr>
-            <a:r>
-              <a:rPr lang="en-US" sz="1100" dirty="0">
-                <a:solidFill>
-                  <a:srgbClr val="F47920"/>
-                </a:solidFill>
-                <a:latin typeface="Calibri" pitchFamily="34" charset="0"/>
-                <a:ea typeface="Calibri" pitchFamily="34" charset="-122"/>
-                <a:cs typeface="Calibri" pitchFamily="34" charset="-120"/>
-              </a:rPr>
-              <a:t>▶</a:t>
-            </a:r>
             <a:endParaRPr lang="en-US" sz="1100" dirty="0"/>
           </a:p>
         </p:txBody>
-      </p:sp>
-      <p:sp>
-        <p:nvSpPr>
-          <p:cNvPr id="33" name="Shape 30"/>
-          <p:cNvSpPr/>
-          <p:nvPr/>
-        </p:nvSpPr>
-        <p:spPr>
-          <a:xfrm>
-            <a:off x="4617720" y="4485132"/>
-            <a:ext cx="1828800" cy="274320"/>
-          </a:xfrm>
-          <a:prstGeom prst="rect">
-            <a:avLst/>
-          </a:prstGeom>
-          <a:solidFill>
-            <a:srgbClr val="FEF0E3"/>
-          </a:solidFill>
-          <a:ln w="12700">
-            <a:solidFill>
-              <a:srgbClr val="F47920"/>
-            </a:solidFill>
-            <a:prstDash val="solid"/>
-          </a:ln>
-        </p:spPr>
       </p:sp>
       <p:sp>
         <p:nvSpPr>
@@ -5080,17 +4961,6 @@
             <a:pPr marL="0" indent="0" algn="ctr">
               <a:buNone/>
             </a:pPr>
-            <a:r>
-              <a:rPr lang="en-US" sz="1000" b="1" dirty="0">
-                <a:solidFill>
-                  <a:srgbClr val="1E3A5F"/>
-                </a:solidFill>
-                <a:latin typeface="Calibri" pitchFamily="34" charset="0"/>
-                <a:ea typeface="Calibri" pitchFamily="34" charset="-122"/>
-                <a:cs typeface="Calibri" pitchFamily="34" charset="-120"/>
-              </a:rPr>
-              <a:t>风险锚体系</a:t>
-            </a:r>
             <a:endParaRPr lang="en-US" sz="1000" dirty="0"/>
           </a:p>
         </p:txBody>
@@ -5118,45 +4988,9 @@
             <a:pPr marL="0" indent="0" algn="ctr">
               <a:buNone/>
             </a:pPr>
-            <a:r>
-              <a:rPr lang="en-US" sz="1100" dirty="0">
-                <a:solidFill>
-                  <a:srgbClr val="F47920"/>
-                </a:solidFill>
-                <a:latin typeface="Calibri" pitchFamily="34" charset="0"/>
-                <a:ea typeface="Calibri" pitchFamily="34" charset="-122"/>
-                <a:cs typeface="Calibri" pitchFamily="34" charset="-120"/>
-              </a:rPr>
-              <a:t>▶</a:t>
-            </a:r>
             <a:endParaRPr lang="en-US" sz="1100" dirty="0"/>
           </a:p>
         </p:txBody>
-      </p:sp>
-      <p:sp>
-        <p:nvSpPr>
-          <p:cNvPr id="36" name="Shape 33"/>
-          <p:cNvSpPr/>
-          <p:nvPr/>
-        </p:nvSpPr>
-        <p:spPr>
-          <a:xfrm>
-            <a:off x="6766560" y="4485132"/>
-            <a:ext cx="1828800" cy="274320"/>
-          </a:xfrm>
-          <a:prstGeom prst="rect">
-            <a:avLst/>
-          </a:prstGeom>
-          <a:solidFill>
-            <a:srgbClr val="1E3A5F"/>
-          </a:solidFill>
-          <a:ln w="12700">
-            <a:solidFill>
-              <a:srgbClr val="1E3A5F"/>
-            </a:solidFill>
-            <a:prstDash val="solid"/>
-          </a:ln>
-        </p:spPr>
       </p:sp>
       <p:sp>
         <p:nvSpPr>
@@ -7746,9 +7580,9 @@
               <a:tblPr/>
               <a:tblGrid>
                 <a:gridCol w="365760"/>
-                <a:gridCol w="548640"/>
-                <a:gridCol w="548640"/>
-                <a:gridCol w="1645920"/>
+                <a:gridCol w="645795"/>
+                <a:gridCol w="608330"/>
+                <a:gridCol w="1489075"/>
               </a:tblGrid>
               <a:tr h="243840">
                 <a:tc>
@@ -10837,56 +10671,6 @@
       </p:sp>
       <p:sp>
         <p:nvSpPr>
-          <p:cNvPr id="4" name="Shape 2"/>
-          <p:cNvSpPr/>
-          <p:nvPr/>
-        </p:nvSpPr>
-        <p:spPr>
-          <a:xfrm>
-            <a:off x="320040" y="512064"/>
-            <a:ext cx="8503920" cy="384048"/>
-          </a:xfrm>
-          <a:prstGeom prst="rect">
-            <a:avLst/>
-          </a:prstGeom>
-          <a:solidFill>
-            <a:srgbClr val="FEF0E3"/>
-          </a:solidFill>
-          <a:ln w="12700">
-            <a:solidFill>
-              <a:srgbClr val="FEF0E3"/>
-            </a:solidFill>
-            <a:prstDash val="solid"/>
-          </a:ln>
-        </p:spPr>
-      </p:sp>
-      <p:sp>
-        <p:nvSpPr>
-          <p:cNvPr id="5" name="Shape 3"/>
-          <p:cNvSpPr/>
-          <p:nvPr/>
-        </p:nvSpPr>
-        <p:spPr>
-          <a:xfrm>
-            <a:off x="320040" y="512064"/>
-            <a:ext cx="54864" cy="384048"/>
-          </a:xfrm>
-          <a:prstGeom prst="rect">
-            <a:avLst/>
-          </a:prstGeom>
-          <a:solidFill>
-            <a:srgbClr val="F47920"/>
-          </a:solidFill>
-          <a:ln w="12700">
-            <a:solidFill>
-              <a:srgbClr val="F47920"/>
-            </a:solidFill>
-            <a:prstDash val="solid"/>
-          </a:ln>
-        </p:spPr>
-      </p:sp>
-      <p:sp>
-        <p:nvSpPr>
           <p:cNvPr id="6" name="Text 4"/>
           <p:cNvSpPr/>
           <p:nvPr/>
@@ -10908,17 +10692,6 @@
             <a:pPr marL="0" indent="0">
               <a:buNone/>
             </a:pPr>
-            <a:r>
-              <a:rPr lang="en-US" sz="1050" i="1" dirty="0">
-                <a:solidFill>
-                  <a:srgbClr val="1E3A5F"/>
-                </a:solidFill>
-                <a:latin typeface="Calibri" pitchFamily="34" charset="0"/>
-                <a:ea typeface="Calibri" pitchFamily="34" charset="-122"/>
-                <a:cs typeface="Calibri" pitchFamily="34" charset="-120"/>
-              </a:rPr>
-              <a:t>在同一风险锚体系下，3.0 的配置权重变化更连续、更贴近风险预算；420 更接近静态规则模板</a:t>
-            </a:r>
             <a:endParaRPr lang="en-US" sz="1050" dirty="0"/>
           </a:p>
         </p:txBody>
@@ -10979,63 +10752,6 @@
       </p:sp>
       <p:sp>
         <p:nvSpPr>
-          <p:cNvPr id="10" name="Shape 8"/>
-          <p:cNvSpPr/>
-          <p:nvPr/>
-        </p:nvSpPr>
-        <p:spPr>
-          <a:xfrm>
-            <a:off x="320040" y="1005840"/>
-            <a:ext cx="4160520" cy="548640"/>
-          </a:xfrm>
-          <a:prstGeom prst="rect">
-            <a:avLst/>
-          </a:prstGeom>
-          <a:solidFill>
-            <a:srgbClr val="FFFAF4"/>
-          </a:solidFill>
-          <a:ln w="12700">
-            <a:solidFill>
-              <a:srgbClr val="F47920"/>
-            </a:solidFill>
-            <a:prstDash val="solid"/>
-          </a:ln>
-          <a:effectLst>
-            <a:outerShdw blurRad="63500" dist="25400" dir="8100000" algn="bl" rotWithShape="0">
-              <a:srgbClr val="000000">
-                <a:alpha val="10000"/>
-              </a:srgbClr>
-            </a:outerShdw>
-          </a:effectLst>
-        </p:spPr>
-      </p:sp>
-      <p:sp>
-        <p:nvSpPr>
-          <p:cNvPr id="11" name="Shape 9"/>
-          <p:cNvSpPr/>
-          <p:nvPr/>
-        </p:nvSpPr>
-        <p:spPr>
-          <a:xfrm>
-            <a:off x="320040" y="1005840"/>
-            <a:ext cx="54864" cy="548640"/>
-          </a:xfrm>
-          <a:prstGeom prst="rect">
-            <a:avLst/>
-          </a:prstGeom>
-          <a:solidFill>
-            <a:srgbClr val="F47920"/>
-          </a:solidFill>
-          <a:ln w="12700">
-            <a:solidFill>
-              <a:srgbClr val="F47920"/>
-            </a:solidFill>
-            <a:prstDash val="solid"/>
-          </a:ln>
-        </p:spPr>
-      </p:sp>
-      <p:sp>
-        <p:nvSpPr>
           <p:cNvPr id="12" name="Text 10"/>
           <p:cNvSpPr/>
           <p:nvPr/>
@@ -11057,17 +10773,6 @@
             <a:pPr marL="0" indent="0">
               <a:buNone/>
             </a:pPr>
-            <a:r>
-              <a:rPr lang="en-US" sz="1100" b="1" dirty="0">
-                <a:solidFill>
-                  <a:srgbClr val="F47920"/>
-                </a:solidFill>
-                <a:latin typeface="Calibri" pitchFamily="34" charset="0"/>
-                <a:ea typeface="Calibri" pitchFamily="34" charset="-122"/>
-                <a:cs typeface="Calibri" pitchFamily="34" charset="-120"/>
-              </a:rPr>
-              <a:t>3.0 策略</a:t>
-            </a:r>
             <a:endParaRPr lang="en-US" sz="1100" dirty="0"/>
           </a:p>
         </p:txBody>
@@ -11095,77 +10800,9 @@
             <a:pPr marL="0" indent="0">
               <a:buNone/>
             </a:pPr>
-            <a:r>
-              <a:rPr lang="en-US" sz="900" dirty="0">
-                <a:solidFill>
-                  <a:srgbClr val="1E3A5F"/>
-                </a:solidFill>
-                <a:latin typeface="Calibri" pitchFamily="34" charset="0"/>
-                <a:ea typeface="Calibri" pitchFamily="34" charset="-122"/>
-                <a:cs typeface="Calibri" pitchFamily="34" charset="-120"/>
-              </a:rPr>
-              <a:t>基于统一四大类资产框架与客户画像风险预算，按画像动态生成配置权重，核心逻辑是在风险预算内最优化资产结构</a:t>
-            </a:r>
             <a:endParaRPr lang="en-US" sz="900" dirty="0"/>
           </a:p>
         </p:txBody>
-      </p:sp>
-      <p:sp>
-        <p:nvSpPr>
-          <p:cNvPr id="14" name="Shape 12"/>
-          <p:cNvSpPr/>
-          <p:nvPr/>
-        </p:nvSpPr>
-        <p:spPr>
-          <a:xfrm>
-            <a:off x="4782312" y="1005840"/>
-            <a:ext cx="4160520" cy="548640"/>
-          </a:xfrm>
-          <a:prstGeom prst="rect">
-            <a:avLst/>
-          </a:prstGeom>
-          <a:solidFill>
-            <a:srgbClr val="FFFAF4"/>
-          </a:solidFill>
-          <a:ln w="12700">
-            <a:solidFill>
-              <a:srgbClr val="1E3A5F"/>
-            </a:solidFill>
-            <a:prstDash val="solid"/>
-          </a:ln>
-          <a:effectLst>
-            <a:outerShdw blurRad="63500" dist="25400" dir="8100000" algn="bl" rotWithShape="0">
-              <a:srgbClr val="000000">
-                <a:alpha val="10000"/>
-              </a:srgbClr>
-            </a:outerShdw>
-          </a:effectLst>
-        </p:spPr>
-      </p:sp>
-      <p:sp>
-        <p:nvSpPr>
-          <p:cNvPr id="15" name="Shape 13"/>
-          <p:cNvSpPr/>
-          <p:nvPr/>
-        </p:nvSpPr>
-        <p:spPr>
-          <a:xfrm>
-            <a:off x="4782312" y="1005840"/>
-            <a:ext cx="54864" cy="548640"/>
-          </a:xfrm>
-          <a:prstGeom prst="rect">
-            <a:avLst/>
-          </a:prstGeom>
-          <a:solidFill>
-            <a:srgbClr val="1E3A5F"/>
-          </a:solidFill>
-          <a:ln w="12700">
-            <a:solidFill>
-              <a:srgbClr val="1E3A5F"/>
-            </a:solidFill>
-            <a:prstDash val="solid"/>
-          </a:ln>
-        </p:spPr>
       </p:sp>
       <p:sp>
         <p:nvSpPr>
@@ -11190,17 +10827,6 @@
             <a:pPr marL="0" indent="0">
               <a:buNone/>
             </a:pPr>
-            <a:r>
-              <a:rPr lang="en-US" sz="1100" b="1" dirty="0">
-                <a:solidFill>
-                  <a:srgbClr val="1E3A5F"/>
-                </a:solidFill>
-                <a:latin typeface="Calibri" pitchFamily="34" charset="0"/>
-                <a:ea typeface="Calibri" pitchFamily="34" charset="-122"/>
-                <a:cs typeface="Calibri" pitchFamily="34" charset="-120"/>
-              </a:rPr>
-              <a:t>420 套策略</a:t>
-            </a:r>
             <a:endParaRPr lang="en-US" sz="1100" dirty="0"/>
           </a:p>
         </p:txBody>
@@ -11213,7 +10839,7 @@
         </p:nvSpPr>
         <p:spPr>
           <a:xfrm>
-            <a:off x="4928616" y="1316736"/>
+            <a:off x="4928616" y="1362456"/>
             <a:ext cx="3886200" cy="201168"/>
           </a:xfrm>
           <a:prstGeom prst="rect">
@@ -11228,17 +10854,6 @@
             <a:pPr marL="0" indent="0">
               <a:buNone/>
             </a:pPr>
-            <a:r>
-              <a:rPr lang="en-US" sz="900" dirty="0">
-                <a:solidFill>
-                  <a:srgbClr val="1E3A5F"/>
-                </a:solidFill>
-                <a:latin typeface="Calibri" pitchFamily="34" charset="0"/>
-                <a:ea typeface="Calibri" pitchFamily="34" charset="-122"/>
-                <a:cs typeface="Calibri" pitchFamily="34" charset="-120"/>
-              </a:rPr>
-              <a:t>基于既有规则库，对不同客户画像给出固定比例配置，优势是规则清晰、可复现、易于审计</a:t>
-            </a:r>
             <a:endParaRPr lang="en-US" sz="900" dirty="0"/>
           </a:p>
         </p:txBody>
@@ -11266,2973 +10881,10 @@
             <a:pPr marL="0" indent="0">
               <a:buNone/>
             </a:pPr>
-            <a:r>
-              <a:rPr lang="en-US" sz="1100" b="1" dirty="0">
-                <a:solidFill>
-                  <a:srgbClr val="1E3A5F"/>
-                </a:solidFill>
-                <a:latin typeface="Calibri" pitchFamily="34" charset="0"/>
-                <a:ea typeface="Calibri" pitchFamily="34" charset="-122"/>
-                <a:cs typeface="Calibri" pitchFamily="34" charset="-120"/>
-              </a:rPr>
-              <a:t>代表性客户画像配置权重对比</a:t>
-            </a:r>
             <a:endParaRPr lang="en-US" sz="1100" dirty="0"/>
           </a:p>
         </p:txBody>
       </p:sp>
-      <p:graphicFrame>
-        <p:nvGraphicFramePr>
-          <p:cNvPr id="19" name="Table 0"/>
-          <p:cNvGraphicFramePr>
-            <a:graphicFrameLocks noGrp="1"/>
-          </p:cNvGraphicFramePr>
-          <p:nvPr/>
-        </p:nvGraphicFramePr>
-        <p:xfrm>
-          <a:off x="320040" y="1883664"/>
-          <a:ext cx="8503920" cy="932688"/>
-        </p:xfrm>
-        <a:graphic>
-          <a:graphicData uri="http://schemas.openxmlformats.org/drawingml/2006/table">
-            <a:tbl>
-              <a:tblPr/>
-              <a:tblGrid>
-                <a:gridCol w="822960"/>
-                <a:gridCol w="822960"/>
-                <a:gridCol w="640080"/>
-                <a:gridCol w="640080"/>
-                <a:gridCol w="548640"/>
-                <a:gridCol w="548640"/>
-                <a:gridCol w="640080"/>
-                <a:gridCol w="640080"/>
-                <a:gridCol w="548640"/>
-                <a:gridCol w="548640"/>
-              </a:tblGrid>
-              <a:tr h="233172">
-                <a:tc>
-                  <a:txBody>
-                    <a:bodyPr/>
-                    <a:lstStyle/>
-                    <a:p>
-                      <a:pPr marL="0" indent="0">
-                        <a:buNone/>
-                      </a:pPr>
-                      <a:r>
-                        <a:rPr lang="en-US" sz="850" b="1" dirty="0">
-                          <a:solidFill>
-                            <a:srgbClr val="FFFFFF"/>
-                          </a:solidFill>
-                          <a:latin typeface="Calibri" pitchFamily="34" charset="0"/>
-                          <a:ea typeface="Calibri" pitchFamily="34" charset="-122"/>
-                          <a:cs typeface="Calibri" pitchFamily="34" charset="-120"/>
-                        </a:rPr>
-                        <a:t>风险等级</a:t>
-                      </a:r>
-                      <a:endParaRPr lang="en-US" sz="850" dirty="0">
-                        <a:latin typeface="Calibri" pitchFamily="34" charset="0"/>
-                        <a:ea typeface="Calibri" pitchFamily="34" charset="0"/>
-                        <a:cs typeface="Calibri" pitchFamily="34" charset="0"/>
-                      </a:endParaRPr>
-                    </a:p>
-                  </a:txBody>
-                  <a:tcPr>
-                    <a:lnL w="8890" cap="flat" cmpd="sng" algn="ctr">
-                      <a:solidFill>
-                        <a:srgbClr val="D8D0C6"/>
-                      </a:solidFill>
-                      <a:prstDash val="solid"/>
-                      <a:round/>
-                      <a:headEnd type="none" w="med" len="med"/>
-                      <a:tailEnd type="none" w="med" len="med"/>
-                    </a:lnL>
-                    <a:lnR w="8890" cap="flat" cmpd="sng" algn="ctr">
-                      <a:solidFill>
-                        <a:srgbClr val="D8D0C6"/>
-                      </a:solidFill>
-                      <a:prstDash val="solid"/>
-                      <a:round/>
-                      <a:headEnd type="none" w="med" len="med"/>
-                      <a:tailEnd type="none" w="med" len="med"/>
-                    </a:lnR>
-                    <a:lnT w="8890" cap="flat" cmpd="sng" algn="ctr">
-                      <a:solidFill>
-                        <a:srgbClr val="D8D0C6"/>
-                      </a:solidFill>
-                      <a:prstDash val="solid"/>
-                      <a:round/>
-                      <a:headEnd type="none" w="med" len="med"/>
-                      <a:tailEnd type="none" w="med" len="med"/>
-                    </a:lnT>
-                    <a:lnB w="8890" cap="flat" cmpd="sng" algn="ctr">
-                      <a:solidFill>
-                        <a:srgbClr val="D8D0C6"/>
-                      </a:solidFill>
-                      <a:prstDash val="solid"/>
-                      <a:round/>
-                      <a:headEnd type="none" w="med" len="med"/>
-                      <a:tailEnd type="none" w="med" len="med"/>
-                    </a:lnB>
-                    <a:solidFill>
-                      <a:srgbClr val="1E3A5F"/>
-                    </a:solidFill>
-                  </a:tcPr>
-                </a:tc>
-                <a:tc>
-                  <a:txBody>
-                    <a:bodyPr/>
-                    <a:lstStyle/>
-                    <a:p>
-                      <a:pPr marL="0" indent="0">
-                        <a:buNone/>
-                      </a:pPr>
-                      <a:r>
-                        <a:rPr lang="en-US" sz="850" b="1" dirty="0">
-                          <a:solidFill>
-                            <a:srgbClr val="FFFFFF"/>
-                          </a:solidFill>
-                          <a:latin typeface="Calibri" pitchFamily="34" charset="0"/>
-                          <a:ea typeface="Calibri" pitchFamily="34" charset="-122"/>
-                          <a:cs typeface="Calibri" pitchFamily="34" charset="-120"/>
-                        </a:rPr>
-                        <a:t>生命周期</a:t>
-                      </a:r>
-                      <a:endParaRPr lang="en-US" sz="850" dirty="0">
-                        <a:latin typeface="Calibri" pitchFamily="34" charset="0"/>
-                        <a:ea typeface="Calibri" pitchFamily="34" charset="0"/>
-                        <a:cs typeface="Calibri" pitchFamily="34" charset="0"/>
-                      </a:endParaRPr>
-                    </a:p>
-                  </a:txBody>
-                  <a:tcPr>
-                    <a:lnL w="8890" cap="flat" cmpd="sng" algn="ctr">
-                      <a:solidFill>
-                        <a:srgbClr val="D8D0C6"/>
-                      </a:solidFill>
-                      <a:prstDash val="solid"/>
-                      <a:round/>
-                      <a:headEnd type="none" w="med" len="med"/>
-                      <a:tailEnd type="none" w="med" len="med"/>
-                    </a:lnL>
-                    <a:lnR w="8890" cap="flat" cmpd="sng" algn="ctr">
-                      <a:solidFill>
-                        <a:srgbClr val="D8D0C6"/>
-                      </a:solidFill>
-                      <a:prstDash val="solid"/>
-                      <a:round/>
-                      <a:headEnd type="none" w="med" len="med"/>
-                      <a:tailEnd type="none" w="med" len="med"/>
-                    </a:lnR>
-                    <a:lnT w="8890" cap="flat" cmpd="sng" algn="ctr">
-                      <a:solidFill>
-                        <a:srgbClr val="D8D0C6"/>
-                      </a:solidFill>
-                      <a:prstDash val="solid"/>
-                      <a:round/>
-                      <a:headEnd type="none" w="med" len="med"/>
-                      <a:tailEnd type="none" w="med" len="med"/>
-                    </a:lnT>
-                    <a:lnB w="8890" cap="flat" cmpd="sng" algn="ctr">
-                      <a:solidFill>
-                        <a:srgbClr val="D8D0C6"/>
-                      </a:solidFill>
-                      <a:prstDash val="solid"/>
-                      <a:round/>
-                      <a:headEnd type="none" w="med" len="med"/>
-                      <a:tailEnd type="none" w="med" len="med"/>
-                    </a:lnB>
-                    <a:solidFill>
-                      <a:srgbClr val="1E3A5F"/>
-                    </a:solidFill>
-                  </a:tcPr>
-                </a:tc>
-                <a:tc>
-                  <a:txBody>
-                    <a:bodyPr/>
-                    <a:lstStyle/>
-                    <a:p>
-                      <a:pPr marL="0" indent="0">
-                        <a:buNone/>
-                      </a:pPr>
-                      <a:r>
-                        <a:rPr lang="en-US" sz="850" b="1" dirty="0">
-                          <a:solidFill>
-                            <a:srgbClr val="FFFFFF"/>
-                          </a:solidFill>
-                          <a:latin typeface="Calibri" pitchFamily="34" charset="0"/>
-                          <a:ea typeface="Calibri" pitchFamily="34" charset="-122"/>
-                          <a:cs typeface="Calibri" pitchFamily="34" charset="-120"/>
-                        </a:rPr>
-                        <a:t>CASH</a:t>
-                      </a:r>
-                      <a:endParaRPr lang="en-US" sz="850" dirty="0">
-                        <a:latin typeface="Calibri" pitchFamily="34" charset="0"/>
-                        <a:ea typeface="Calibri" pitchFamily="34" charset="0"/>
-                        <a:cs typeface="Calibri" pitchFamily="34" charset="0"/>
-                      </a:endParaRPr>
-                    </a:p>
-                    <a:p>
-                      <a:pPr marL="0" indent="0">
-                        <a:buNone/>
-                      </a:pPr>
-                      <a:r>
-                        <a:rPr lang="en-US" sz="850" b="1" dirty="0">
-                          <a:solidFill>
-                            <a:srgbClr val="FFFFFF"/>
-                          </a:solidFill>
-                          <a:latin typeface="Calibri" pitchFamily="34" charset="0"/>
-                          <a:ea typeface="Calibri" pitchFamily="34" charset="-122"/>
-                          <a:cs typeface="Calibri" pitchFamily="34" charset="-120"/>
-                        </a:rPr>
-                        <a:t>3.0</a:t>
-                      </a:r>
-                      <a:endParaRPr lang="en-US" sz="850" dirty="0">
-                        <a:latin typeface="Calibri" pitchFamily="34" charset="0"/>
-                        <a:ea typeface="Calibri" pitchFamily="34" charset="0"/>
-                        <a:cs typeface="Calibri" pitchFamily="34" charset="0"/>
-                      </a:endParaRPr>
-                    </a:p>
-                  </a:txBody>
-                  <a:tcPr>
-                    <a:lnL w="8890" cap="flat" cmpd="sng" algn="ctr">
-                      <a:solidFill>
-                        <a:srgbClr val="D8D0C6"/>
-                      </a:solidFill>
-                      <a:prstDash val="solid"/>
-                      <a:round/>
-                      <a:headEnd type="none" w="med" len="med"/>
-                      <a:tailEnd type="none" w="med" len="med"/>
-                    </a:lnL>
-                    <a:lnR w="8890" cap="flat" cmpd="sng" algn="ctr">
-                      <a:solidFill>
-                        <a:srgbClr val="D8D0C6"/>
-                      </a:solidFill>
-                      <a:prstDash val="solid"/>
-                      <a:round/>
-                      <a:headEnd type="none" w="med" len="med"/>
-                      <a:tailEnd type="none" w="med" len="med"/>
-                    </a:lnR>
-                    <a:lnT w="8890" cap="flat" cmpd="sng" algn="ctr">
-                      <a:solidFill>
-                        <a:srgbClr val="D8D0C6"/>
-                      </a:solidFill>
-                      <a:prstDash val="solid"/>
-                      <a:round/>
-                      <a:headEnd type="none" w="med" len="med"/>
-                      <a:tailEnd type="none" w="med" len="med"/>
-                    </a:lnT>
-                    <a:lnB w="8890" cap="flat" cmpd="sng" algn="ctr">
-                      <a:solidFill>
-                        <a:srgbClr val="D8D0C6"/>
-                      </a:solidFill>
-                      <a:prstDash val="solid"/>
-                      <a:round/>
-                      <a:headEnd type="none" w="med" len="med"/>
-                      <a:tailEnd type="none" w="med" len="med"/>
-                    </a:lnB>
-                    <a:solidFill>
-                      <a:srgbClr val="F47920"/>
-                    </a:solidFill>
-                  </a:tcPr>
-                </a:tc>
-                <a:tc>
-                  <a:txBody>
-                    <a:bodyPr/>
-                    <a:lstStyle/>
-                    <a:p>
-                      <a:pPr marL="0" indent="0">
-                        <a:buNone/>
-                      </a:pPr>
-                      <a:r>
-                        <a:rPr lang="en-US" sz="850" b="1" dirty="0">
-                          <a:solidFill>
-                            <a:srgbClr val="FFFFFF"/>
-                          </a:solidFill>
-                          <a:latin typeface="Calibri" pitchFamily="34" charset="0"/>
-                          <a:ea typeface="Calibri" pitchFamily="34" charset="-122"/>
-                          <a:cs typeface="Calibri" pitchFamily="34" charset="-120"/>
-                        </a:rPr>
-                        <a:t>BOND</a:t>
-                      </a:r>
-                      <a:endParaRPr lang="en-US" sz="850" dirty="0">
-                        <a:latin typeface="Calibri" pitchFamily="34" charset="0"/>
-                        <a:ea typeface="Calibri" pitchFamily="34" charset="0"/>
-                        <a:cs typeface="Calibri" pitchFamily="34" charset="0"/>
-                      </a:endParaRPr>
-                    </a:p>
-                    <a:p>
-                      <a:pPr marL="0" indent="0">
-                        <a:buNone/>
-                      </a:pPr>
-                      <a:r>
-                        <a:rPr lang="en-US" sz="850" b="1" dirty="0">
-                          <a:solidFill>
-                            <a:srgbClr val="FFFFFF"/>
-                          </a:solidFill>
-                          <a:latin typeface="Calibri" pitchFamily="34" charset="0"/>
-                          <a:ea typeface="Calibri" pitchFamily="34" charset="-122"/>
-                          <a:cs typeface="Calibri" pitchFamily="34" charset="-120"/>
-                        </a:rPr>
-                        <a:t>3.0</a:t>
-                      </a:r>
-                      <a:endParaRPr lang="en-US" sz="850" dirty="0">
-                        <a:latin typeface="Calibri" pitchFamily="34" charset="0"/>
-                        <a:ea typeface="Calibri" pitchFamily="34" charset="0"/>
-                        <a:cs typeface="Calibri" pitchFamily="34" charset="0"/>
-                      </a:endParaRPr>
-                    </a:p>
-                  </a:txBody>
-                  <a:tcPr>
-                    <a:lnL w="8890" cap="flat" cmpd="sng" algn="ctr">
-                      <a:solidFill>
-                        <a:srgbClr val="D8D0C6"/>
-                      </a:solidFill>
-                      <a:prstDash val="solid"/>
-                      <a:round/>
-                      <a:headEnd type="none" w="med" len="med"/>
-                      <a:tailEnd type="none" w="med" len="med"/>
-                    </a:lnL>
-                    <a:lnR w="8890" cap="flat" cmpd="sng" algn="ctr">
-                      <a:solidFill>
-                        <a:srgbClr val="D8D0C6"/>
-                      </a:solidFill>
-                      <a:prstDash val="solid"/>
-                      <a:round/>
-                      <a:headEnd type="none" w="med" len="med"/>
-                      <a:tailEnd type="none" w="med" len="med"/>
-                    </a:lnR>
-                    <a:lnT w="8890" cap="flat" cmpd="sng" algn="ctr">
-                      <a:solidFill>
-                        <a:srgbClr val="D8D0C6"/>
-                      </a:solidFill>
-                      <a:prstDash val="solid"/>
-                      <a:round/>
-                      <a:headEnd type="none" w="med" len="med"/>
-                      <a:tailEnd type="none" w="med" len="med"/>
-                    </a:lnT>
-                    <a:lnB w="8890" cap="flat" cmpd="sng" algn="ctr">
-                      <a:solidFill>
-                        <a:srgbClr val="D8D0C6"/>
-                      </a:solidFill>
-                      <a:prstDash val="solid"/>
-                      <a:round/>
-                      <a:headEnd type="none" w="med" len="med"/>
-                      <a:tailEnd type="none" w="med" len="med"/>
-                    </a:lnB>
-                    <a:solidFill>
-                      <a:srgbClr val="F47920"/>
-                    </a:solidFill>
-                  </a:tcPr>
-                </a:tc>
-                <a:tc>
-                  <a:txBody>
-                    <a:bodyPr/>
-                    <a:lstStyle/>
-                    <a:p>
-                      <a:pPr marL="0" indent="0">
-                        <a:buNone/>
-                      </a:pPr>
-                      <a:r>
-                        <a:rPr lang="en-US" sz="850" b="1" dirty="0">
-                          <a:solidFill>
-                            <a:srgbClr val="FFFFFF"/>
-                          </a:solidFill>
-                          <a:latin typeface="Calibri" pitchFamily="34" charset="0"/>
-                          <a:ea typeface="Calibri" pitchFamily="34" charset="-122"/>
-                          <a:cs typeface="Calibri" pitchFamily="34" charset="-120"/>
-                        </a:rPr>
-                        <a:t>EQ</a:t>
-                      </a:r>
-                      <a:endParaRPr lang="en-US" sz="850" dirty="0">
-                        <a:latin typeface="Calibri" pitchFamily="34" charset="0"/>
-                        <a:ea typeface="Calibri" pitchFamily="34" charset="0"/>
-                        <a:cs typeface="Calibri" pitchFamily="34" charset="0"/>
-                      </a:endParaRPr>
-                    </a:p>
-                    <a:p>
-                      <a:pPr marL="0" indent="0">
-                        <a:buNone/>
-                      </a:pPr>
-                      <a:r>
-                        <a:rPr lang="en-US" sz="850" b="1" dirty="0">
-                          <a:solidFill>
-                            <a:srgbClr val="FFFFFF"/>
-                          </a:solidFill>
-                          <a:latin typeface="Calibri" pitchFamily="34" charset="0"/>
-                          <a:ea typeface="Calibri" pitchFamily="34" charset="-122"/>
-                          <a:cs typeface="Calibri" pitchFamily="34" charset="-120"/>
-                        </a:rPr>
-                        <a:t>3.0</a:t>
-                      </a:r>
-                      <a:endParaRPr lang="en-US" sz="850" dirty="0">
-                        <a:latin typeface="Calibri" pitchFamily="34" charset="0"/>
-                        <a:ea typeface="Calibri" pitchFamily="34" charset="0"/>
-                        <a:cs typeface="Calibri" pitchFamily="34" charset="0"/>
-                      </a:endParaRPr>
-                    </a:p>
-                  </a:txBody>
-                  <a:tcPr>
-                    <a:lnL w="8890" cap="flat" cmpd="sng" algn="ctr">
-                      <a:solidFill>
-                        <a:srgbClr val="D8D0C6"/>
-                      </a:solidFill>
-                      <a:prstDash val="solid"/>
-                      <a:round/>
-                      <a:headEnd type="none" w="med" len="med"/>
-                      <a:tailEnd type="none" w="med" len="med"/>
-                    </a:lnL>
-                    <a:lnR w="8890" cap="flat" cmpd="sng" algn="ctr">
-                      <a:solidFill>
-                        <a:srgbClr val="D8D0C6"/>
-                      </a:solidFill>
-                      <a:prstDash val="solid"/>
-                      <a:round/>
-                      <a:headEnd type="none" w="med" len="med"/>
-                      <a:tailEnd type="none" w="med" len="med"/>
-                    </a:lnR>
-                    <a:lnT w="8890" cap="flat" cmpd="sng" algn="ctr">
-                      <a:solidFill>
-                        <a:srgbClr val="D8D0C6"/>
-                      </a:solidFill>
-                      <a:prstDash val="solid"/>
-                      <a:round/>
-                      <a:headEnd type="none" w="med" len="med"/>
-                      <a:tailEnd type="none" w="med" len="med"/>
-                    </a:lnT>
-                    <a:lnB w="8890" cap="flat" cmpd="sng" algn="ctr">
-                      <a:solidFill>
-                        <a:srgbClr val="D8D0C6"/>
-                      </a:solidFill>
-                      <a:prstDash val="solid"/>
-                      <a:round/>
-                      <a:headEnd type="none" w="med" len="med"/>
-                      <a:tailEnd type="none" w="med" len="med"/>
-                    </a:lnB>
-                    <a:solidFill>
-                      <a:srgbClr val="F47920"/>
-                    </a:solidFill>
-                  </a:tcPr>
-                </a:tc>
-                <a:tc>
-                  <a:txBody>
-                    <a:bodyPr/>
-                    <a:lstStyle/>
-                    <a:p>
-                      <a:pPr marL="0" indent="0">
-                        <a:buNone/>
-                      </a:pPr>
-                      <a:r>
-                        <a:rPr lang="en-US" sz="850" b="1" dirty="0">
-                          <a:solidFill>
-                            <a:srgbClr val="FFFFFF"/>
-                          </a:solidFill>
-                          <a:latin typeface="Calibri" pitchFamily="34" charset="0"/>
-                          <a:ea typeface="Calibri" pitchFamily="34" charset="-122"/>
-                          <a:cs typeface="Calibri" pitchFamily="34" charset="-120"/>
-                        </a:rPr>
-                        <a:t>ALT</a:t>
-                      </a:r>
-                      <a:endParaRPr lang="en-US" sz="850" dirty="0">
-                        <a:latin typeface="Calibri" pitchFamily="34" charset="0"/>
-                        <a:ea typeface="Calibri" pitchFamily="34" charset="0"/>
-                        <a:cs typeface="Calibri" pitchFamily="34" charset="0"/>
-                      </a:endParaRPr>
-                    </a:p>
-                    <a:p>
-                      <a:pPr marL="0" indent="0">
-                        <a:buNone/>
-                      </a:pPr>
-                      <a:r>
-                        <a:rPr lang="en-US" sz="850" b="1" dirty="0">
-                          <a:solidFill>
-                            <a:srgbClr val="FFFFFF"/>
-                          </a:solidFill>
-                          <a:latin typeface="Calibri" pitchFamily="34" charset="0"/>
-                          <a:ea typeface="Calibri" pitchFamily="34" charset="-122"/>
-                          <a:cs typeface="Calibri" pitchFamily="34" charset="-120"/>
-                        </a:rPr>
-                        <a:t>3.0</a:t>
-                      </a:r>
-                      <a:endParaRPr lang="en-US" sz="850" dirty="0">
-                        <a:latin typeface="Calibri" pitchFamily="34" charset="0"/>
-                        <a:ea typeface="Calibri" pitchFamily="34" charset="0"/>
-                        <a:cs typeface="Calibri" pitchFamily="34" charset="0"/>
-                      </a:endParaRPr>
-                    </a:p>
-                  </a:txBody>
-                  <a:tcPr>
-                    <a:lnL w="8890" cap="flat" cmpd="sng" algn="ctr">
-                      <a:solidFill>
-                        <a:srgbClr val="D8D0C6"/>
-                      </a:solidFill>
-                      <a:prstDash val="solid"/>
-                      <a:round/>
-                      <a:headEnd type="none" w="med" len="med"/>
-                      <a:tailEnd type="none" w="med" len="med"/>
-                    </a:lnL>
-                    <a:lnR w="8890" cap="flat" cmpd="sng" algn="ctr">
-                      <a:solidFill>
-                        <a:srgbClr val="D8D0C6"/>
-                      </a:solidFill>
-                      <a:prstDash val="solid"/>
-                      <a:round/>
-                      <a:headEnd type="none" w="med" len="med"/>
-                      <a:tailEnd type="none" w="med" len="med"/>
-                    </a:lnR>
-                    <a:lnT w="8890" cap="flat" cmpd="sng" algn="ctr">
-                      <a:solidFill>
-                        <a:srgbClr val="D8D0C6"/>
-                      </a:solidFill>
-                      <a:prstDash val="solid"/>
-                      <a:round/>
-                      <a:headEnd type="none" w="med" len="med"/>
-                      <a:tailEnd type="none" w="med" len="med"/>
-                    </a:lnT>
-                    <a:lnB w="8890" cap="flat" cmpd="sng" algn="ctr">
-                      <a:solidFill>
-                        <a:srgbClr val="D8D0C6"/>
-                      </a:solidFill>
-                      <a:prstDash val="solid"/>
-                      <a:round/>
-                      <a:headEnd type="none" w="med" len="med"/>
-                      <a:tailEnd type="none" w="med" len="med"/>
-                    </a:lnB>
-                    <a:solidFill>
-                      <a:srgbClr val="F47920"/>
-                    </a:solidFill>
-                  </a:tcPr>
-                </a:tc>
-                <a:tc>
-                  <a:txBody>
-                    <a:bodyPr/>
-                    <a:lstStyle/>
-                    <a:p>
-                      <a:pPr marL="0" indent="0">
-                        <a:buNone/>
-                      </a:pPr>
-                      <a:r>
-                        <a:rPr lang="en-US" sz="850" b="1" dirty="0">
-                          <a:solidFill>
-                            <a:srgbClr val="FFFFFF"/>
-                          </a:solidFill>
-                          <a:latin typeface="Calibri" pitchFamily="34" charset="0"/>
-                          <a:ea typeface="Calibri" pitchFamily="34" charset="-122"/>
-                          <a:cs typeface="Calibri" pitchFamily="34" charset="-120"/>
-                        </a:rPr>
-                        <a:t>CASH</a:t>
-                      </a:r>
-                      <a:endParaRPr lang="en-US" sz="850" dirty="0">
-                        <a:latin typeface="Calibri" pitchFamily="34" charset="0"/>
-                        <a:ea typeface="Calibri" pitchFamily="34" charset="0"/>
-                        <a:cs typeface="Calibri" pitchFamily="34" charset="0"/>
-                      </a:endParaRPr>
-                    </a:p>
-                    <a:p>
-                      <a:pPr marL="0" indent="0">
-                        <a:buNone/>
-                      </a:pPr>
-                      <a:r>
-                        <a:rPr lang="en-US" sz="850" b="1" dirty="0">
-                          <a:solidFill>
-                            <a:srgbClr val="FFFFFF"/>
-                          </a:solidFill>
-                          <a:latin typeface="Calibri" pitchFamily="34" charset="0"/>
-                          <a:ea typeface="Calibri" pitchFamily="34" charset="-122"/>
-                          <a:cs typeface="Calibri" pitchFamily="34" charset="-120"/>
-                        </a:rPr>
-                        <a:t>420</a:t>
-                      </a:r>
-                      <a:endParaRPr lang="en-US" sz="850" dirty="0">
-                        <a:latin typeface="Calibri" pitchFamily="34" charset="0"/>
-                        <a:ea typeface="Calibri" pitchFamily="34" charset="0"/>
-                        <a:cs typeface="Calibri" pitchFamily="34" charset="0"/>
-                      </a:endParaRPr>
-                    </a:p>
-                  </a:txBody>
-                  <a:tcPr>
-                    <a:lnL w="8890" cap="flat" cmpd="sng" algn="ctr">
-                      <a:solidFill>
-                        <a:srgbClr val="D8D0C6"/>
-                      </a:solidFill>
-                      <a:prstDash val="solid"/>
-                      <a:round/>
-                      <a:headEnd type="none" w="med" len="med"/>
-                      <a:tailEnd type="none" w="med" len="med"/>
-                    </a:lnL>
-                    <a:lnR w="8890" cap="flat" cmpd="sng" algn="ctr">
-                      <a:solidFill>
-                        <a:srgbClr val="D8D0C6"/>
-                      </a:solidFill>
-                      <a:prstDash val="solid"/>
-                      <a:round/>
-                      <a:headEnd type="none" w="med" len="med"/>
-                      <a:tailEnd type="none" w="med" len="med"/>
-                    </a:lnR>
-                    <a:lnT w="8890" cap="flat" cmpd="sng" algn="ctr">
-                      <a:solidFill>
-                        <a:srgbClr val="D8D0C6"/>
-                      </a:solidFill>
-                      <a:prstDash val="solid"/>
-                      <a:round/>
-                      <a:headEnd type="none" w="med" len="med"/>
-                      <a:tailEnd type="none" w="med" len="med"/>
-                    </a:lnT>
-                    <a:lnB w="8890" cap="flat" cmpd="sng" algn="ctr">
-                      <a:solidFill>
-                        <a:srgbClr val="D8D0C6"/>
-                      </a:solidFill>
-                      <a:prstDash val="solid"/>
-                      <a:round/>
-                      <a:headEnd type="none" w="med" len="med"/>
-                      <a:tailEnd type="none" w="med" len="med"/>
-                    </a:lnB>
-                    <a:solidFill>
-                      <a:srgbClr val="1E3A5F"/>
-                    </a:solidFill>
-                  </a:tcPr>
-                </a:tc>
-                <a:tc>
-                  <a:txBody>
-                    <a:bodyPr/>
-                    <a:lstStyle/>
-                    <a:p>
-                      <a:pPr marL="0" indent="0">
-                        <a:buNone/>
-                      </a:pPr>
-                      <a:r>
-                        <a:rPr lang="en-US" sz="850" b="1" dirty="0">
-                          <a:solidFill>
-                            <a:srgbClr val="FFFFFF"/>
-                          </a:solidFill>
-                          <a:latin typeface="Calibri" pitchFamily="34" charset="0"/>
-                          <a:ea typeface="Calibri" pitchFamily="34" charset="-122"/>
-                          <a:cs typeface="Calibri" pitchFamily="34" charset="-120"/>
-                        </a:rPr>
-                        <a:t>BOND</a:t>
-                      </a:r>
-                      <a:endParaRPr lang="en-US" sz="850" dirty="0">
-                        <a:latin typeface="Calibri" pitchFamily="34" charset="0"/>
-                        <a:ea typeface="Calibri" pitchFamily="34" charset="0"/>
-                        <a:cs typeface="Calibri" pitchFamily="34" charset="0"/>
-                      </a:endParaRPr>
-                    </a:p>
-                    <a:p>
-                      <a:pPr marL="0" indent="0">
-                        <a:buNone/>
-                      </a:pPr>
-                      <a:r>
-                        <a:rPr lang="en-US" sz="850" b="1" dirty="0">
-                          <a:solidFill>
-                            <a:srgbClr val="FFFFFF"/>
-                          </a:solidFill>
-                          <a:latin typeface="Calibri" pitchFamily="34" charset="0"/>
-                          <a:ea typeface="Calibri" pitchFamily="34" charset="-122"/>
-                          <a:cs typeface="Calibri" pitchFamily="34" charset="-120"/>
-                        </a:rPr>
-                        <a:t>420</a:t>
-                      </a:r>
-                      <a:endParaRPr lang="en-US" sz="850" dirty="0">
-                        <a:latin typeface="Calibri" pitchFamily="34" charset="0"/>
-                        <a:ea typeface="Calibri" pitchFamily="34" charset="0"/>
-                        <a:cs typeface="Calibri" pitchFamily="34" charset="0"/>
-                      </a:endParaRPr>
-                    </a:p>
-                  </a:txBody>
-                  <a:tcPr>
-                    <a:lnL w="8890" cap="flat" cmpd="sng" algn="ctr">
-                      <a:solidFill>
-                        <a:srgbClr val="D8D0C6"/>
-                      </a:solidFill>
-                      <a:prstDash val="solid"/>
-                      <a:round/>
-                      <a:headEnd type="none" w="med" len="med"/>
-                      <a:tailEnd type="none" w="med" len="med"/>
-                    </a:lnL>
-                    <a:lnR w="8890" cap="flat" cmpd="sng" algn="ctr">
-                      <a:solidFill>
-                        <a:srgbClr val="D8D0C6"/>
-                      </a:solidFill>
-                      <a:prstDash val="solid"/>
-                      <a:round/>
-                      <a:headEnd type="none" w="med" len="med"/>
-                      <a:tailEnd type="none" w="med" len="med"/>
-                    </a:lnR>
-                    <a:lnT w="8890" cap="flat" cmpd="sng" algn="ctr">
-                      <a:solidFill>
-                        <a:srgbClr val="D8D0C6"/>
-                      </a:solidFill>
-                      <a:prstDash val="solid"/>
-                      <a:round/>
-                      <a:headEnd type="none" w="med" len="med"/>
-                      <a:tailEnd type="none" w="med" len="med"/>
-                    </a:lnT>
-                    <a:lnB w="8890" cap="flat" cmpd="sng" algn="ctr">
-                      <a:solidFill>
-                        <a:srgbClr val="D8D0C6"/>
-                      </a:solidFill>
-                      <a:prstDash val="solid"/>
-                      <a:round/>
-                      <a:headEnd type="none" w="med" len="med"/>
-                      <a:tailEnd type="none" w="med" len="med"/>
-                    </a:lnB>
-                    <a:solidFill>
-                      <a:srgbClr val="1E3A5F"/>
-                    </a:solidFill>
-                  </a:tcPr>
-                </a:tc>
-                <a:tc>
-                  <a:txBody>
-                    <a:bodyPr/>
-                    <a:lstStyle/>
-                    <a:p>
-                      <a:pPr marL="0" indent="0">
-                        <a:buNone/>
-                      </a:pPr>
-                      <a:r>
-                        <a:rPr lang="en-US" sz="850" b="1" dirty="0">
-                          <a:solidFill>
-                            <a:srgbClr val="FFFFFF"/>
-                          </a:solidFill>
-                          <a:latin typeface="Calibri" pitchFamily="34" charset="0"/>
-                          <a:ea typeface="Calibri" pitchFamily="34" charset="-122"/>
-                          <a:cs typeface="Calibri" pitchFamily="34" charset="-120"/>
-                        </a:rPr>
-                        <a:t>EQ</a:t>
-                      </a:r>
-                      <a:endParaRPr lang="en-US" sz="850" dirty="0">
-                        <a:latin typeface="Calibri" pitchFamily="34" charset="0"/>
-                        <a:ea typeface="Calibri" pitchFamily="34" charset="0"/>
-                        <a:cs typeface="Calibri" pitchFamily="34" charset="0"/>
-                      </a:endParaRPr>
-                    </a:p>
-                    <a:p>
-                      <a:pPr marL="0" indent="0">
-                        <a:buNone/>
-                      </a:pPr>
-                      <a:r>
-                        <a:rPr lang="en-US" sz="850" b="1" dirty="0">
-                          <a:solidFill>
-                            <a:srgbClr val="FFFFFF"/>
-                          </a:solidFill>
-                          <a:latin typeface="Calibri" pitchFamily="34" charset="0"/>
-                          <a:ea typeface="Calibri" pitchFamily="34" charset="-122"/>
-                          <a:cs typeface="Calibri" pitchFamily="34" charset="-120"/>
-                        </a:rPr>
-                        <a:t>420</a:t>
-                      </a:r>
-                      <a:endParaRPr lang="en-US" sz="850" dirty="0">
-                        <a:latin typeface="Calibri" pitchFamily="34" charset="0"/>
-                        <a:ea typeface="Calibri" pitchFamily="34" charset="0"/>
-                        <a:cs typeface="Calibri" pitchFamily="34" charset="0"/>
-                      </a:endParaRPr>
-                    </a:p>
-                  </a:txBody>
-                  <a:tcPr>
-                    <a:lnL w="8890" cap="flat" cmpd="sng" algn="ctr">
-                      <a:solidFill>
-                        <a:srgbClr val="D8D0C6"/>
-                      </a:solidFill>
-                      <a:prstDash val="solid"/>
-                      <a:round/>
-                      <a:headEnd type="none" w="med" len="med"/>
-                      <a:tailEnd type="none" w="med" len="med"/>
-                    </a:lnL>
-                    <a:lnR w="8890" cap="flat" cmpd="sng" algn="ctr">
-                      <a:solidFill>
-                        <a:srgbClr val="D8D0C6"/>
-                      </a:solidFill>
-                      <a:prstDash val="solid"/>
-                      <a:round/>
-                      <a:headEnd type="none" w="med" len="med"/>
-                      <a:tailEnd type="none" w="med" len="med"/>
-                    </a:lnR>
-                    <a:lnT w="8890" cap="flat" cmpd="sng" algn="ctr">
-                      <a:solidFill>
-                        <a:srgbClr val="D8D0C6"/>
-                      </a:solidFill>
-                      <a:prstDash val="solid"/>
-                      <a:round/>
-                      <a:headEnd type="none" w="med" len="med"/>
-                      <a:tailEnd type="none" w="med" len="med"/>
-                    </a:lnT>
-                    <a:lnB w="8890" cap="flat" cmpd="sng" algn="ctr">
-                      <a:solidFill>
-                        <a:srgbClr val="D8D0C6"/>
-                      </a:solidFill>
-                      <a:prstDash val="solid"/>
-                      <a:round/>
-                      <a:headEnd type="none" w="med" len="med"/>
-                      <a:tailEnd type="none" w="med" len="med"/>
-                    </a:lnB>
-                    <a:solidFill>
-                      <a:srgbClr val="1E3A5F"/>
-                    </a:solidFill>
-                  </a:tcPr>
-                </a:tc>
-                <a:tc>
-                  <a:txBody>
-                    <a:bodyPr/>
-                    <a:lstStyle/>
-                    <a:p>
-                      <a:pPr marL="0" indent="0">
-                        <a:buNone/>
-                      </a:pPr>
-                      <a:r>
-                        <a:rPr lang="en-US" sz="850" b="1" dirty="0">
-                          <a:solidFill>
-                            <a:srgbClr val="FFFFFF"/>
-                          </a:solidFill>
-                          <a:latin typeface="Calibri" pitchFamily="34" charset="0"/>
-                          <a:ea typeface="Calibri" pitchFamily="34" charset="-122"/>
-                          <a:cs typeface="Calibri" pitchFamily="34" charset="-120"/>
-                        </a:rPr>
-                        <a:t>ALT</a:t>
-                      </a:r>
-                      <a:endParaRPr lang="en-US" sz="850" dirty="0">
-                        <a:latin typeface="Calibri" pitchFamily="34" charset="0"/>
-                        <a:ea typeface="Calibri" pitchFamily="34" charset="0"/>
-                        <a:cs typeface="Calibri" pitchFamily="34" charset="0"/>
-                      </a:endParaRPr>
-                    </a:p>
-                    <a:p>
-                      <a:pPr marL="0" indent="0">
-                        <a:buNone/>
-                      </a:pPr>
-                      <a:r>
-                        <a:rPr lang="en-US" sz="850" b="1" dirty="0">
-                          <a:solidFill>
-                            <a:srgbClr val="FFFFFF"/>
-                          </a:solidFill>
-                          <a:latin typeface="Calibri" pitchFamily="34" charset="0"/>
-                          <a:ea typeface="Calibri" pitchFamily="34" charset="-122"/>
-                          <a:cs typeface="Calibri" pitchFamily="34" charset="-120"/>
-                        </a:rPr>
-                        <a:t>420</a:t>
-                      </a:r>
-                      <a:endParaRPr lang="en-US" sz="850" dirty="0">
-                        <a:latin typeface="Calibri" pitchFamily="34" charset="0"/>
-                        <a:ea typeface="Calibri" pitchFamily="34" charset="0"/>
-                        <a:cs typeface="Calibri" pitchFamily="34" charset="0"/>
-                      </a:endParaRPr>
-                    </a:p>
-                  </a:txBody>
-                  <a:tcPr>
-                    <a:lnL w="8890" cap="flat" cmpd="sng" algn="ctr">
-                      <a:solidFill>
-                        <a:srgbClr val="D8D0C6"/>
-                      </a:solidFill>
-                      <a:prstDash val="solid"/>
-                      <a:round/>
-                      <a:headEnd type="none" w="med" len="med"/>
-                      <a:tailEnd type="none" w="med" len="med"/>
-                    </a:lnL>
-                    <a:lnR w="8890" cap="flat" cmpd="sng" algn="ctr">
-                      <a:solidFill>
-                        <a:srgbClr val="D8D0C6"/>
-                      </a:solidFill>
-                      <a:prstDash val="solid"/>
-                      <a:round/>
-                      <a:headEnd type="none" w="med" len="med"/>
-                      <a:tailEnd type="none" w="med" len="med"/>
-                    </a:lnR>
-                    <a:lnT w="8890" cap="flat" cmpd="sng" algn="ctr">
-                      <a:solidFill>
-                        <a:srgbClr val="D8D0C6"/>
-                      </a:solidFill>
-                      <a:prstDash val="solid"/>
-                      <a:round/>
-                      <a:headEnd type="none" w="med" len="med"/>
-                      <a:tailEnd type="none" w="med" len="med"/>
-                    </a:lnT>
-                    <a:lnB w="8890" cap="flat" cmpd="sng" algn="ctr">
-                      <a:solidFill>
-                        <a:srgbClr val="D8D0C6"/>
-                      </a:solidFill>
-                      <a:prstDash val="solid"/>
-                      <a:round/>
-                      <a:headEnd type="none" w="med" len="med"/>
-                      <a:tailEnd type="none" w="med" len="med"/>
-                    </a:lnB>
-                    <a:solidFill>
-                      <a:srgbClr val="1E3A5F"/>
-                    </a:solidFill>
-                  </a:tcPr>
-                </a:tc>
-              </a:tr>
-              <a:tr h="233172">
-                <a:tc>
-                  <a:txBody>
-                    <a:bodyPr/>
-                    <a:lstStyle/>
-                    <a:p>
-                      <a:pPr marL="0" indent="0" algn="l">
-                        <a:buNone/>
-                      </a:pPr>
-                      <a:r>
-                        <a:rPr lang="en-US" sz="900" dirty="0">
-                          <a:solidFill>
-                            <a:srgbClr val="1E3A5F"/>
-                          </a:solidFill>
-                          <a:latin typeface="Calibri" pitchFamily="34" charset="0"/>
-                          <a:ea typeface="Calibri" pitchFamily="34" charset="-122"/>
-                          <a:cs typeface="Calibri" pitchFamily="34" charset="-120"/>
-                        </a:rPr>
-                        <a:t>C1 保守</a:t>
-                      </a:r>
-                      <a:endParaRPr lang="en-US" sz="900" dirty="0">
-                        <a:latin typeface="Calibri" pitchFamily="34" charset="0"/>
-                        <a:ea typeface="Calibri" pitchFamily="34" charset="0"/>
-                        <a:cs typeface="Calibri" pitchFamily="34" charset="0"/>
-                      </a:endParaRPr>
-                    </a:p>
-                  </a:txBody>
-                  <a:tcPr>
-                    <a:lnL w="8890" cap="flat" cmpd="sng" algn="ctr">
-                      <a:solidFill>
-                        <a:srgbClr val="D8D0C6"/>
-                      </a:solidFill>
-                      <a:prstDash val="solid"/>
-                      <a:round/>
-                      <a:headEnd type="none" w="med" len="med"/>
-                      <a:tailEnd type="none" w="med" len="med"/>
-                    </a:lnL>
-                    <a:lnR w="8890" cap="flat" cmpd="sng" algn="ctr">
-                      <a:solidFill>
-                        <a:srgbClr val="D8D0C6"/>
-                      </a:solidFill>
-                      <a:prstDash val="solid"/>
-                      <a:round/>
-                      <a:headEnd type="none" w="med" len="med"/>
-                      <a:tailEnd type="none" w="med" len="med"/>
-                    </a:lnR>
-                    <a:lnT w="8890" cap="flat" cmpd="sng" algn="ctr">
-                      <a:solidFill>
-                        <a:srgbClr val="D8D0C6"/>
-                      </a:solidFill>
-                      <a:prstDash val="solid"/>
-                      <a:round/>
-                      <a:headEnd type="none" w="med" len="med"/>
-                      <a:tailEnd type="none" w="med" len="med"/>
-                    </a:lnT>
-                    <a:lnB w="8890" cap="flat" cmpd="sng" algn="ctr">
-                      <a:solidFill>
-                        <a:srgbClr val="D8D0C6"/>
-                      </a:solidFill>
-                      <a:prstDash val="solid"/>
-                      <a:round/>
-                      <a:headEnd type="none" w="med" len="med"/>
-                      <a:tailEnd type="none" w="med" len="med"/>
-                    </a:lnB>
-                    <a:solidFill>
-                      <a:srgbClr val="FFFAF4"/>
-                    </a:solidFill>
-                  </a:tcPr>
-                </a:tc>
-                <a:tc>
-                  <a:txBody>
-                    <a:bodyPr/>
-                    <a:lstStyle/>
-                    <a:p>
-                      <a:pPr marL="0" indent="0" algn="l">
-                        <a:buNone/>
-                      </a:pPr>
-                      <a:r>
-                        <a:rPr lang="en-US" sz="900" dirty="0">
-                          <a:solidFill>
-                            <a:srgbClr val="1E3A5F"/>
-                          </a:solidFill>
-                          <a:latin typeface="Calibri" pitchFamily="34" charset="0"/>
-                          <a:ea typeface="Calibri" pitchFamily="34" charset="-122"/>
-                          <a:cs typeface="Calibri" pitchFamily="34" charset="-120"/>
-                        </a:rPr>
-                        <a:t>S4 小孩学前</a:t>
-                      </a:r>
-                      <a:endParaRPr lang="en-US" sz="900" dirty="0">
-                        <a:latin typeface="Calibri" pitchFamily="34" charset="0"/>
-                        <a:ea typeface="Calibri" pitchFamily="34" charset="0"/>
-                        <a:cs typeface="Calibri" pitchFamily="34" charset="0"/>
-                      </a:endParaRPr>
-                    </a:p>
-                  </a:txBody>
-                  <a:tcPr>
-                    <a:lnL w="8890" cap="flat" cmpd="sng" algn="ctr">
-                      <a:solidFill>
-                        <a:srgbClr val="D8D0C6"/>
-                      </a:solidFill>
-                      <a:prstDash val="solid"/>
-                      <a:round/>
-                      <a:headEnd type="none" w="med" len="med"/>
-                      <a:tailEnd type="none" w="med" len="med"/>
-                    </a:lnL>
-                    <a:lnR w="8890" cap="flat" cmpd="sng" algn="ctr">
-                      <a:solidFill>
-                        <a:srgbClr val="D8D0C6"/>
-                      </a:solidFill>
-                      <a:prstDash val="solid"/>
-                      <a:round/>
-                      <a:headEnd type="none" w="med" len="med"/>
-                      <a:tailEnd type="none" w="med" len="med"/>
-                    </a:lnR>
-                    <a:lnT w="8890" cap="flat" cmpd="sng" algn="ctr">
-                      <a:solidFill>
-                        <a:srgbClr val="D8D0C6"/>
-                      </a:solidFill>
-                      <a:prstDash val="solid"/>
-                      <a:round/>
-                      <a:headEnd type="none" w="med" len="med"/>
-                      <a:tailEnd type="none" w="med" len="med"/>
-                    </a:lnT>
-                    <a:lnB w="8890" cap="flat" cmpd="sng" algn="ctr">
-                      <a:solidFill>
-                        <a:srgbClr val="D8D0C6"/>
-                      </a:solidFill>
-                      <a:prstDash val="solid"/>
-                      <a:round/>
-                      <a:headEnd type="none" w="med" len="med"/>
-                      <a:tailEnd type="none" w="med" len="med"/>
-                    </a:lnB>
-                    <a:solidFill>
-                      <a:srgbClr val="FFFAF4"/>
-                    </a:solidFill>
-                  </a:tcPr>
-                </a:tc>
-                <a:tc>
-                  <a:txBody>
-                    <a:bodyPr/>
-                    <a:lstStyle/>
-                    <a:p>
-                      <a:pPr marL="0" indent="0" algn="ctr">
-                        <a:buNone/>
-                      </a:pPr>
-                      <a:r>
-                        <a:rPr lang="en-US" sz="900" dirty="0">
-                          <a:solidFill>
-                            <a:srgbClr val="1E3A5F"/>
-                          </a:solidFill>
-                          <a:latin typeface="Calibri" pitchFamily="34" charset="0"/>
-                          <a:ea typeface="Calibri" pitchFamily="34" charset="-122"/>
-                          <a:cs typeface="Calibri" pitchFamily="34" charset="-120"/>
-                        </a:rPr>
-                        <a:t>40%</a:t>
-                      </a:r>
-                      <a:endParaRPr lang="en-US" sz="900" dirty="0">
-                        <a:latin typeface="Calibri" pitchFamily="34" charset="0"/>
-                        <a:ea typeface="Calibri" pitchFamily="34" charset="0"/>
-                        <a:cs typeface="Calibri" pitchFamily="34" charset="0"/>
-                      </a:endParaRPr>
-                    </a:p>
-                  </a:txBody>
-                  <a:tcPr>
-                    <a:lnL w="8890" cap="flat" cmpd="sng" algn="ctr">
-                      <a:solidFill>
-                        <a:srgbClr val="D8D0C6"/>
-                      </a:solidFill>
-                      <a:prstDash val="solid"/>
-                      <a:round/>
-                      <a:headEnd type="none" w="med" len="med"/>
-                      <a:tailEnd type="none" w="med" len="med"/>
-                    </a:lnL>
-                    <a:lnR w="8890" cap="flat" cmpd="sng" algn="ctr">
-                      <a:solidFill>
-                        <a:srgbClr val="D8D0C6"/>
-                      </a:solidFill>
-                      <a:prstDash val="solid"/>
-                      <a:round/>
-                      <a:headEnd type="none" w="med" len="med"/>
-                      <a:tailEnd type="none" w="med" len="med"/>
-                    </a:lnR>
-                    <a:lnT w="8890" cap="flat" cmpd="sng" algn="ctr">
-                      <a:solidFill>
-                        <a:srgbClr val="D8D0C6"/>
-                      </a:solidFill>
-                      <a:prstDash val="solid"/>
-                      <a:round/>
-                      <a:headEnd type="none" w="med" len="med"/>
-                      <a:tailEnd type="none" w="med" len="med"/>
-                    </a:lnT>
-                    <a:lnB w="8890" cap="flat" cmpd="sng" algn="ctr">
-                      <a:solidFill>
-                        <a:srgbClr val="D8D0C6"/>
-                      </a:solidFill>
-                      <a:prstDash val="solid"/>
-                      <a:round/>
-                      <a:headEnd type="none" w="med" len="med"/>
-                      <a:tailEnd type="none" w="med" len="med"/>
-                    </a:lnB>
-                    <a:solidFill>
-                      <a:srgbClr val="FEF5EC"/>
-                    </a:solidFill>
-                  </a:tcPr>
-                </a:tc>
-                <a:tc>
-                  <a:txBody>
-                    <a:bodyPr/>
-                    <a:lstStyle/>
-                    <a:p>
-                      <a:pPr marL="0" indent="0" algn="ctr">
-                        <a:buNone/>
-                      </a:pPr>
-                      <a:r>
-                        <a:rPr lang="en-US" sz="900" dirty="0">
-                          <a:solidFill>
-                            <a:srgbClr val="1E3A5F"/>
-                          </a:solidFill>
-                          <a:latin typeface="Calibri" pitchFamily="34" charset="0"/>
-                          <a:ea typeface="Calibri" pitchFamily="34" charset="-122"/>
-                          <a:cs typeface="Calibri" pitchFamily="34" charset="-120"/>
-                        </a:rPr>
-                        <a:t>60%</a:t>
-                      </a:r>
-                      <a:endParaRPr lang="en-US" sz="900" dirty="0">
-                        <a:latin typeface="Calibri" pitchFamily="34" charset="0"/>
-                        <a:ea typeface="Calibri" pitchFamily="34" charset="0"/>
-                        <a:cs typeface="Calibri" pitchFamily="34" charset="0"/>
-                      </a:endParaRPr>
-                    </a:p>
-                  </a:txBody>
-                  <a:tcPr>
-                    <a:lnL w="8890" cap="flat" cmpd="sng" algn="ctr">
-                      <a:solidFill>
-                        <a:srgbClr val="D8D0C6"/>
-                      </a:solidFill>
-                      <a:prstDash val="solid"/>
-                      <a:round/>
-                      <a:headEnd type="none" w="med" len="med"/>
-                      <a:tailEnd type="none" w="med" len="med"/>
-                    </a:lnL>
-                    <a:lnR w="8890" cap="flat" cmpd="sng" algn="ctr">
-                      <a:solidFill>
-                        <a:srgbClr val="D8D0C6"/>
-                      </a:solidFill>
-                      <a:prstDash val="solid"/>
-                      <a:round/>
-                      <a:headEnd type="none" w="med" len="med"/>
-                      <a:tailEnd type="none" w="med" len="med"/>
-                    </a:lnR>
-                    <a:lnT w="8890" cap="flat" cmpd="sng" algn="ctr">
-                      <a:solidFill>
-                        <a:srgbClr val="D8D0C6"/>
-                      </a:solidFill>
-                      <a:prstDash val="solid"/>
-                      <a:round/>
-                      <a:headEnd type="none" w="med" len="med"/>
-                      <a:tailEnd type="none" w="med" len="med"/>
-                    </a:lnT>
-                    <a:lnB w="8890" cap="flat" cmpd="sng" algn="ctr">
-                      <a:solidFill>
-                        <a:srgbClr val="D8D0C6"/>
-                      </a:solidFill>
-                      <a:prstDash val="solid"/>
-                      <a:round/>
-                      <a:headEnd type="none" w="med" len="med"/>
-                      <a:tailEnd type="none" w="med" len="med"/>
-                    </a:lnB>
-                    <a:solidFill>
-                      <a:srgbClr val="FEF5EC"/>
-                    </a:solidFill>
-                  </a:tcPr>
-                </a:tc>
-                <a:tc>
-                  <a:txBody>
-                    <a:bodyPr/>
-                    <a:lstStyle/>
-                    <a:p>
-                      <a:pPr marL="0" indent="0" algn="ctr">
-                        <a:buNone/>
-                      </a:pPr>
-                      <a:r>
-                        <a:rPr lang="en-US" sz="900" dirty="0">
-                          <a:solidFill>
-                            <a:srgbClr val="1E3A5F"/>
-                          </a:solidFill>
-                          <a:latin typeface="Calibri" pitchFamily="34" charset="0"/>
-                          <a:ea typeface="Calibri" pitchFamily="34" charset="-122"/>
-                          <a:cs typeface="Calibri" pitchFamily="34" charset="-120"/>
-                        </a:rPr>
-                        <a:t>0%</a:t>
-                      </a:r>
-                      <a:endParaRPr lang="en-US" sz="900" dirty="0">
-                        <a:latin typeface="Calibri" pitchFamily="34" charset="0"/>
-                        <a:ea typeface="Calibri" pitchFamily="34" charset="0"/>
-                        <a:cs typeface="Calibri" pitchFamily="34" charset="0"/>
-                      </a:endParaRPr>
-                    </a:p>
-                  </a:txBody>
-                  <a:tcPr>
-                    <a:lnL w="8890" cap="flat" cmpd="sng" algn="ctr">
-                      <a:solidFill>
-                        <a:srgbClr val="D8D0C6"/>
-                      </a:solidFill>
-                      <a:prstDash val="solid"/>
-                      <a:round/>
-                      <a:headEnd type="none" w="med" len="med"/>
-                      <a:tailEnd type="none" w="med" len="med"/>
-                    </a:lnL>
-                    <a:lnR w="8890" cap="flat" cmpd="sng" algn="ctr">
-                      <a:solidFill>
-                        <a:srgbClr val="D8D0C6"/>
-                      </a:solidFill>
-                      <a:prstDash val="solid"/>
-                      <a:round/>
-                      <a:headEnd type="none" w="med" len="med"/>
-                      <a:tailEnd type="none" w="med" len="med"/>
-                    </a:lnR>
-                    <a:lnT w="8890" cap="flat" cmpd="sng" algn="ctr">
-                      <a:solidFill>
-                        <a:srgbClr val="D8D0C6"/>
-                      </a:solidFill>
-                      <a:prstDash val="solid"/>
-                      <a:round/>
-                      <a:headEnd type="none" w="med" len="med"/>
-                      <a:tailEnd type="none" w="med" len="med"/>
-                    </a:lnT>
-                    <a:lnB w="8890" cap="flat" cmpd="sng" algn="ctr">
-                      <a:solidFill>
-                        <a:srgbClr val="D8D0C6"/>
-                      </a:solidFill>
-                      <a:prstDash val="solid"/>
-                      <a:round/>
-                      <a:headEnd type="none" w="med" len="med"/>
-                      <a:tailEnd type="none" w="med" len="med"/>
-                    </a:lnB>
-                    <a:solidFill>
-                      <a:srgbClr val="FEF5EC"/>
-                    </a:solidFill>
-                  </a:tcPr>
-                </a:tc>
-                <a:tc>
-                  <a:txBody>
-                    <a:bodyPr/>
-                    <a:lstStyle/>
-                    <a:p>
-                      <a:pPr marL="0" indent="0" algn="ctr">
-                        <a:buNone/>
-                      </a:pPr>
-                      <a:r>
-                        <a:rPr lang="en-US" sz="900" dirty="0">
-                          <a:solidFill>
-                            <a:srgbClr val="1E3A5F"/>
-                          </a:solidFill>
-                          <a:latin typeface="Calibri" pitchFamily="34" charset="0"/>
-                          <a:ea typeface="Calibri" pitchFamily="34" charset="-122"/>
-                          <a:cs typeface="Calibri" pitchFamily="34" charset="-120"/>
-                        </a:rPr>
-                        <a:t>0%</a:t>
-                      </a:r>
-                      <a:endParaRPr lang="en-US" sz="900" dirty="0">
-                        <a:latin typeface="Calibri" pitchFamily="34" charset="0"/>
-                        <a:ea typeface="Calibri" pitchFamily="34" charset="0"/>
-                        <a:cs typeface="Calibri" pitchFamily="34" charset="0"/>
-                      </a:endParaRPr>
-                    </a:p>
-                  </a:txBody>
-                  <a:tcPr>
-                    <a:lnL w="8890" cap="flat" cmpd="sng" algn="ctr">
-                      <a:solidFill>
-                        <a:srgbClr val="D8D0C6"/>
-                      </a:solidFill>
-                      <a:prstDash val="solid"/>
-                      <a:round/>
-                      <a:headEnd type="none" w="med" len="med"/>
-                      <a:tailEnd type="none" w="med" len="med"/>
-                    </a:lnL>
-                    <a:lnR w="8890" cap="flat" cmpd="sng" algn="ctr">
-                      <a:solidFill>
-                        <a:srgbClr val="D8D0C6"/>
-                      </a:solidFill>
-                      <a:prstDash val="solid"/>
-                      <a:round/>
-                      <a:headEnd type="none" w="med" len="med"/>
-                      <a:tailEnd type="none" w="med" len="med"/>
-                    </a:lnR>
-                    <a:lnT w="8890" cap="flat" cmpd="sng" algn="ctr">
-                      <a:solidFill>
-                        <a:srgbClr val="D8D0C6"/>
-                      </a:solidFill>
-                      <a:prstDash val="solid"/>
-                      <a:round/>
-                      <a:headEnd type="none" w="med" len="med"/>
-                      <a:tailEnd type="none" w="med" len="med"/>
-                    </a:lnT>
-                    <a:lnB w="8890" cap="flat" cmpd="sng" algn="ctr">
-                      <a:solidFill>
-                        <a:srgbClr val="D8D0C6"/>
-                      </a:solidFill>
-                      <a:prstDash val="solid"/>
-                      <a:round/>
-                      <a:headEnd type="none" w="med" len="med"/>
-                      <a:tailEnd type="none" w="med" len="med"/>
-                    </a:lnB>
-                    <a:solidFill>
-                      <a:srgbClr val="FEF5EC"/>
-                    </a:solidFill>
-                  </a:tcPr>
-                </a:tc>
-                <a:tc>
-                  <a:txBody>
-                    <a:bodyPr/>
-                    <a:lstStyle/>
-                    <a:p>
-                      <a:pPr marL="0" indent="0" algn="ctr">
-                        <a:buNone/>
-                      </a:pPr>
-                      <a:r>
-                        <a:rPr lang="en-US" sz="900" dirty="0">
-                          <a:solidFill>
-                            <a:srgbClr val="1E3A5F"/>
-                          </a:solidFill>
-                          <a:latin typeface="Calibri" pitchFamily="34" charset="0"/>
-                          <a:ea typeface="Calibri" pitchFamily="34" charset="-122"/>
-                          <a:cs typeface="Calibri" pitchFamily="34" charset="-120"/>
-                        </a:rPr>
-                        <a:t>65%</a:t>
-                      </a:r>
-                      <a:endParaRPr lang="en-US" sz="900" dirty="0">
-                        <a:latin typeface="Calibri" pitchFamily="34" charset="0"/>
-                        <a:ea typeface="Calibri" pitchFamily="34" charset="0"/>
-                        <a:cs typeface="Calibri" pitchFamily="34" charset="0"/>
-                      </a:endParaRPr>
-                    </a:p>
-                  </a:txBody>
-                  <a:tcPr>
-                    <a:lnL w="8890" cap="flat" cmpd="sng" algn="ctr">
-                      <a:solidFill>
-                        <a:srgbClr val="D8D0C6"/>
-                      </a:solidFill>
-                      <a:prstDash val="solid"/>
-                      <a:round/>
-                      <a:headEnd type="none" w="med" len="med"/>
-                      <a:tailEnd type="none" w="med" len="med"/>
-                    </a:lnL>
-                    <a:lnR w="8890" cap="flat" cmpd="sng" algn="ctr">
-                      <a:solidFill>
-                        <a:srgbClr val="D8D0C6"/>
-                      </a:solidFill>
-                      <a:prstDash val="solid"/>
-                      <a:round/>
-                      <a:headEnd type="none" w="med" len="med"/>
-                      <a:tailEnd type="none" w="med" len="med"/>
-                    </a:lnR>
-                    <a:lnT w="8890" cap="flat" cmpd="sng" algn="ctr">
-                      <a:solidFill>
-                        <a:srgbClr val="D8D0C6"/>
-                      </a:solidFill>
-                      <a:prstDash val="solid"/>
-                      <a:round/>
-                      <a:headEnd type="none" w="med" len="med"/>
-                      <a:tailEnd type="none" w="med" len="med"/>
-                    </a:lnT>
-                    <a:lnB w="8890" cap="flat" cmpd="sng" algn="ctr">
-                      <a:solidFill>
-                        <a:srgbClr val="D8D0C6"/>
-                      </a:solidFill>
-                      <a:prstDash val="solid"/>
-                      <a:round/>
-                      <a:headEnd type="none" w="med" len="med"/>
-                      <a:tailEnd type="none" w="med" len="med"/>
-                    </a:lnB>
-                    <a:solidFill>
-                      <a:srgbClr val="EDF2F8"/>
-                    </a:solidFill>
-                  </a:tcPr>
-                </a:tc>
-                <a:tc>
-                  <a:txBody>
-                    <a:bodyPr/>
-                    <a:lstStyle/>
-                    <a:p>
-                      <a:pPr marL="0" indent="0" algn="ctr">
-                        <a:buNone/>
-                      </a:pPr>
-                      <a:r>
-                        <a:rPr lang="en-US" sz="900" dirty="0">
-                          <a:solidFill>
-                            <a:srgbClr val="1E3A5F"/>
-                          </a:solidFill>
-                          <a:latin typeface="Calibri" pitchFamily="34" charset="0"/>
-                          <a:ea typeface="Calibri" pitchFamily="34" charset="-122"/>
-                          <a:cs typeface="Calibri" pitchFamily="34" charset="-120"/>
-                        </a:rPr>
-                        <a:t>35%</a:t>
-                      </a:r>
-                      <a:endParaRPr lang="en-US" sz="900" dirty="0">
-                        <a:latin typeface="Calibri" pitchFamily="34" charset="0"/>
-                        <a:ea typeface="Calibri" pitchFamily="34" charset="0"/>
-                        <a:cs typeface="Calibri" pitchFamily="34" charset="0"/>
-                      </a:endParaRPr>
-                    </a:p>
-                  </a:txBody>
-                  <a:tcPr>
-                    <a:lnL w="8890" cap="flat" cmpd="sng" algn="ctr">
-                      <a:solidFill>
-                        <a:srgbClr val="D8D0C6"/>
-                      </a:solidFill>
-                      <a:prstDash val="solid"/>
-                      <a:round/>
-                      <a:headEnd type="none" w="med" len="med"/>
-                      <a:tailEnd type="none" w="med" len="med"/>
-                    </a:lnL>
-                    <a:lnR w="8890" cap="flat" cmpd="sng" algn="ctr">
-                      <a:solidFill>
-                        <a:srgbClr val="D8D0C6"/>
-                      </a:solidFill>
-                      <a:prstDash val="solid"/>
-                      <a:round/>
-                      <a:headEnd type="none" w="med" len="med"/>
-                      <a:tailEnd type="none" w="med" len="med"/>
-                    </a:lnR>
-                    <a:lnT w="8890" cap="flat" cmpd="sng" algn="ctr">
-                      <a:solidFill>
-                        <a:srgbClr val="D8D0C6"/>
-                      </a:solidFill>
-                      <a:prstDash val="solid"/>
-                      <a:round/>
-                      <a:headEnd type="none" w="med" len="med"/>
-                      <a:tailEnd type="none" w="med" len="med"/>
-                    </a:lnT>
-                    <a:lnB w="8890" cap="flat" cmpd="sng" algn="ctr">
-                      <a:solidFill>
-                        <a:srgbClr val="D8D0C6"/>
-                      </a:solidFill>
-                      <a:prstDash val="solid"/>
-                      <a:round/>
-                      <a:headEnd type="none" w="med" len="med"/>
-                      <a:tailEnd type="none" w="med" len="med"/>
-                    </a:lnB>
-                    <a:solidFill>
-                      <a:srgbClr val="EDF2F8"/>
-                    </a:solidFill>
-                  </a:tcPr>
-                </a:tc>
-                <a:tc>
-                  <a:txBody>
-                    <a:bodyPr/>
-                    <a:lstStyle/>
-                    <a:p>
-                      <a:pPr marL="0" indent="0" algn="ctr">
-                        <a:buNone/>
-                      </a:pPr>
-                      <a:r>
-                        <a:rPr lang="en-US" sz="900" dirty="0">
-                          <a:solidFill>
-                            <a:srgbClr val="1E3A5F"/>
-                          </a:solidFill>
-                          <a:latin typeface="Calibri" pitchFamily="34" charset="0"/>
-                          <a:ea typeface="Calibri" pitchFamily="34" charset="-122"/>
-                          <a:cs typeface="Calibri" pitchFamily="34" charset="-120"/>
-                        </a:rPr>
-                        <a:t>0%</a:t>
-                      </a:r>
-                      <a:endParaRPr lang="en-US" sz="900" dirty="0">
-                        <a:latin typeface="Calibri" pitchFamily="34" charset="0"/>
-                        <a:ea typeface="Calibri" pitchFamily="34" charset="0"/>
-                        <a:cs typeface="Calibri" pitchFamily="34" charset="0"/>
-                      </a:endParaRPr>
-                    </a:p>
-                  </a:txBody>
-                  <a:tcPr>
-                    <a:lnL w="8890" cap="flat" cmpd="sng" algn="ctr">
-                      <a:solidFill>
-                        <a:srgbClr val="D8D0C6"/>
-                      </a:solidFill>
-                      <a:prstDash val="solid"/>
-                      <a:round/>
-                      <a:headEnd type="none" w="med" len="med"/>
-                      <a:tailEnd type="none" w="med" len="med"/>
-                    </a:lnL>
-                    <a:lnR w="8890" cap="flat" cmpd="sng" algn="ctr">
-                      <a:solidFill>
-                        <a:srgbClr val="D8D0C6"/>
-                      </a:solidFill>
-                      <a:prstDash val="solid"/>
-                      <a:round/>
-                      <a:headEnd type="none" w="med" len="med"/>
-                      <a:tailEnd type="none" w="med" len="med"/>
-                    </a:lnR>
-                    <a:lnT w="8890" cap="flat" cmpd="sng" algn="ctr">
-                      <a:solidFill>
-                        <a:srgbClr val="D8D0C6"/>
-                      </a:solidFill>
-                      <a:prstDash val="solid"/>
-                      <a:round/>
-                      <a:headEnd type="none" w="med" len="med"/>
-                      <a:tailEnd type="none" w="med" len="med"/>
-                    </a:lnT>
-                    <a:lnB w="8890" cap="flat" cmpd="sng" algn="ctr">
-                      <a:solidFill>
-                        <a:srgbClr val="D8D0C6"/>
-                      </a:solidFill>
-                      <a:prstDash val="solid"/>
-                      <a:round/>
-                      <a:headEnd type="none" w="med" len="med"/>
-                      <a:tailEnd type="none" w="med" len="med"/>
-                    </a:lnB>
-                    <a:solidFill>
-                      <a:srgbClr val="EDF2F8"/>
-                    </a:solidFill>
-                  </a:tcPr>
-                </a:tc>
-                <a:tc>
-                  <a:txBody>
-                    <a:bodyPr/>
-                    <a:lstStyle/>
-                    <a:p>
-                      <a:pPr marL="0" indent="0" algn="ctr">
-                        <a:buNone/>
-                      </a:pPr>
-                      <a:r>
-                        <a:rPr lang="en-US" sz="900" dirty="0">
-                          <a:solidFill>
-                            <a:srgbClr val="1E3A5F"/>
-                          </a:solidFill>
-                          <a:latin typeface="Calibri" pitchFamily="34" charset="0"/>
-                          <a:ea typeface="Calibri" pitchFamily="34" charset="-122"/>
-                          <a:cs typeface="Calibri" pitchFamily="34" charset="-120"/>
-                        </a:rPr>
-                        <a:t>0%</a:t>
-                      </a:r>
-                      <a:endParaRPr lang="en-US" sz="900" dirty="0">
-                        <a:latin typeface="Calibri" pitchFamily="34" charset="0"/>
-                        <a:ea typeface="Calibri" pitchFamily="34" charset="0"/>
-                        <a:cs typeface="Calibri" pitchFamily="34" charset="0"/>
-                      </a:endParaRPr>
-                    </a:p>
-                  </a:txBody>
-                  <a:tcPr>
-                    <a:lnL w="8890" cap="flat" cmpd="sng" algn="ctr">
-                      <a:solidFill>
-                        <a:srgbClr val="D8D0C6"/>
-                      </a:solidFill>
-                      <a:prstDash val="solid"/>
-                      <a:round/>
-                      <a:headEnd type="none" w="med" len="med"/>
-                      <a:tailEnd type="none" w="med" len="med"/>
-                    </a:lnL>
-                    <a:lnR w="8890" cap="flat" cmpd="sng" algn="ctr">
-                      <a:solidFill>
-                        <a:srgbClr val="D8D0C6"/>
-                      </a:solidFill>
-                      <a:prstDash val="solid"/>
-                      <a:round/>
-                      <a:headEnd type="none" w="med" len="med"/>
-                      <a:tailEnd type="none" w="med" len="med"/>
-                    </a:lnR>
-                    <a:lnT w="8890" cap="flat" cmpd="sng" algn="ctr">
-                      <a:solidFill>
-                        <a:srgbClr val="D8D0C6"/>
-                      </a:solidFill>
-                      <a:prstDash val="solid"/>
-                      <a:round/>
-                      <a:headEnd type="none" w="med" len="med"/>
-                      <a:tailEnd type="none" w="med" len="med"/>
-                    </a:lnT>
-                    <a:lnB w="8890" cap="flat" cmpd="sng" algn="ctr">
-                      <a:solidFill>
-                        <a:srgbClr val="D8D0C6"/>
-                      </a:solidFill>
-                      <a:prstDash val="solid"/>
-                      <a:round/>
-                      <a:headEnd type="none" w="med" len="med"/>
-                      <a:tailEnd type="none" w="med" len="med"/>
-                    </a:lnB>
-                    <a:solidFill>
-                      <a:srgbClr val="EDF2F8"/>
-                    </a:solidFill>
-                  </a:tcPr>
-                </a:tc>
-              </a:tr>
-              <a:tr h="233172">
-                <a:tc>
-                  <a:txBody>
-                    <a:bodyPr/>
-                    <a:lstStyle/>
-                    <a:p>
-                      <a:pPr marL="0" indent="0" algn="l">
-                        <a:buNone/>
-                      </a:pPr>
-                      <a:r>
-                        <a:rPr lang="en-US" sz="900" dirty="0">
-                          <a:solidFill>
-                            <a:srgbClr val="1E3A5F"/>
-                          </a:solidFill>
-                          <a:latin typeface="Calibri" pitchFamily="34" charset="0"/>
-                          <a:ea typeface="Calibri" pitchFamily="34" charset="-122"/>
-                          <a:cs typeface="Calibri" pitchFamily="34" charset="-120"/>
-                        </a:rPr>
-                        <a:t>C3 平衡</a:t>
-                      </a:r>
-                      <a:endParaRPr lang="en-US" sz="900" dirty="0">
-                        <a:latin typeface="Calibri" pitchFamily="34" charset="0"/>
-                        <a:ea typeface="Calibri" pitchFamily="34" charset="0"/>
-                        <a:cs typeface="Calibri" pitchFamily="34" charset="0"/>
-                      </a:endParaRPr>
-                    </a:p>
-                  </a:txBody>
-                  <a:tcPr>
-                    <a:lnL w="8890" cap="flat" cmpd="sng" algn="ctr">
-                      <a:solidFill>
-                        <a:srgbClr val="D8D0C6"/>
-                      </a:solidFill>
-                      <a:prstDash val="solid"/>
-                      <a:round/>
-                      <a:headEnd type="none" w="med" len="med"/>
-                      <a:tailEnd type="none" w="med" len="med"/>
-                    </a:lnL>
-                    <a:lnR w="8890" cap="flat" cmpd="sng" algn="ctr">
-                      <a:solidFill>
-                        <a:srgbClr val="D8D0C6"/>
-                      </a:solidFill>
-                      <a:prstDash val="solid"/>
-                      <a:round/>
-                      <a:headEnd type="none" w="med" len="med"/>
-                      <a:tailEnd type="none" w="med" len="med"/>
-                    </a:lnR>
-                    <a:lnT w="8890" cap="flat" cmpd="sng" algn="ctr">
-                      <a:solidFill>
-                        <a:srgbClr val="D8D0C6"/>
-                      </a:solidFill>
-                      <a:prstDash val="solid"/>
-                      <a:round/>
-                      <a:headEnd type="none" w="med" len="med"/>
-                      <a:tailEnd type="none" w="med" len="med"/>
-                    </a:lnT>
-                    <a:lnB w="8890" cap="flat" cmpd="sng" algn="ctr">
-                      <a:solidFill>
-                        <a:srgbClr val="D8D0C6"/>
-                      </a:solidFill>
-                      <a:prstDash val="solid"/>
-                      <a:round/>
-                      <a:headEnd type="none" w="med" len="med"/>
-                      <a:tailEnd type="none" w="med" len="med"/>
-                    </a:lnB>
-                    <a:solidFill>
-                      <a:srgbClr val="F5F2EE"/>
-                    </a:solidFill>
-                  </a:tcPr>
-                </a:tc>
-                <a:tc>
-                  <a:txBody>
-                    <a:bodyPr/>
-                    <a:lstStyle/>
-                    <a:p>
-                      <a:pPr marL="0" indent="0" algn="l">
-                        <a:buNone/>
-                      </a:pPr>
-                      <a:r>
-                        <a:rPr lang="en-US" sz="900" dirty="0">
-                          <a:solidFill>
-                            <a:srgbClr val="1E3A5F"/>
-                          </a:solidFill>
-                          <a:latin typeface="Calibri" pitchFamily="34" charset="0"/>
-                          <a:ea typeface="Calibri" pitchFamily="34" charset="-122"/>
-                          <a:cs typeface="Calibri" pitchFamily="34" charset="-120"/>
-                        </a:rPr>
-                        <a:t>S4 小孩学前</a:t>
-                      </a:r>
-                      <a:endParaRPr lang="en-US" sz="900" dirty="0">
-                        <a:latin typeface="Calibri" pitchFamily="34" charset="0"/>
-                        <a:ea typeface="Calibri" pitchFamily="34" charset="0"/>
-                        <a:cs typeface="Calibri" pitchFamily="34" charset="0"/>
-                      </a:endParaRPr>
-                    </a:p>
-                  </a:txBody>
-                  <a:tcPr>
-                    <a:lnL w="8890" cap="flat" cmpd="sng" algn="ctr">
-                      <a:solidFill>
-                        <a:srgbClr val="D8D0C6"/>
-                      </a:solidFill>
-                      <a:prstDash val="solid"/>
-                      <a:round/>
-                      <a:headEnd type="none" w="med" len="med"/>
-                      <a:tailEnd type="none" w="med" len="med"/>
-                    </a:lnL>
-                    <a:lnR w="8890" cap="flat" cmpd="sng" algn="ctr">
-                      <a:solidFill>
-                        <a:srgbClr val="D8D0C6"/>
-                      </a:solidFill>
-                      <a:prstDash val="solid"/>
-                      <a:round/>
-                      <a:headEnd type="none" w="med" len="med"/>
-                      <a:tailEnd type="none" w="med" len="med"/>
-                    </a:lnR>
-                    <a:lnT w="8890" cap="flat" cmpd="sng" algn="ctr">
-                      <a:solidFill>
-                        <a:srgbClr val="D8D0C6"/>
-                      </a:solidFill>
-                      <a:prstDash val="solid"/>
-                      <a:round/>
-                      <a:headEnd type="none" w="med" len="med"/>
-                      <a:tailEnd type="none" w="med" len="med"/>
-                    </a:lnT>
-                    <a:lnB w="8890" cap="flat" cmpd="sng" algn="ctr">
-                      <a:solidFill>
-                        <a:srgbClr val="D8D0C6"/>
-                      </a:solidFill>
-                      <a:prstDash val="solid"/>
-                      <a:round/>
-                      <a:headEnd type="none" w="med" len="med"/>
-                      <a:tailEnd type="none" w="med" len="med"/>
-                    </a:lnB>
-                    <a:solidFill>
-                      <a:srgbClr val="F5F2EE"/>
-                    </a:solidFill>
-                  </a:tcPr>
-                </a:tc>
-                <a:tc>
-                  <a:txBody>
-                    <a:bodyPr/>
-                    <a:lstStyle/>
-                    <a:p>
-                      <a:pPr marL="0" indent="0" algn="ctr">
-                        <a:buNone/>
-                      </a:pPr>
-                      <a:r>
-                        <a:rPr lang="en-US" sz="900" dirty="0">
-                          <a:solidFill>
-                            <a:srgbClr val="1E3A5F"/>
-                          </a:solidFill>
-                          <a:latin typeface="Calibri" pitchFamily="34" charset="0"/>
-                          <a:ea typeface="Calibri" pitchFamily="34" charset="-122"/>
-                          <a:cs typeface="Calibri" pitchFamily="34" charset="-120"/>
-                        </a:rPr>
-                        <a:t>10%</a:t>
-                      </a:r>
-                      <a:endParaRPr lang="en-US" sz="900" dirty="0">
-                        <a:latin typeface="Calibri" pitchFamily="34" charset="0"/>
-                        <a:ea typeface="Calibri" pitchFamily="34" charset="0"/>
-                        <a:cs typeface="Calibri" pitchFamily="34" charset="0"/>
-                      </a:endParaRPr>
-                    </a:p>
-                  </a:txBody>
-                  <a:tcPr>
-                    <a:lnL w="8890" cap="flat" cmpd="sng" algn="ctr">
-                      <a:solidFill>
-                        <a:srgbClr val="D8D0C6"/>
-                      </a:solidFill>
-                      <a:prstDash val="solid"/>
-                      <a:round/>
-                      <a:headEnd type="none" w="med" len="med"/>
-                      <a:tailEnd type="none" w="med" len="med"/>
-                    </a:lnL>
-                    <a:lnR w="8890" cap="flat" cmpd="sng" algn="ctr">
-                      <a:solidFill>
-                        <a:srgbClr val="D8D0C6"/>
-                      </a:solidFill>
-                      <a:prstDash val="solid"/>
-                      <a:round/>
-                      <a:headEnd type="none" w="med" len="med"/>
-                      <a:tailEnd type="none" w="med" len="med"/>
-                    </a:lnR>
-                    <a:lnT w="8890" cap="flat" cmpd="sng" algn="ctr">
-                      <a:solidFill>
-                        <a:srgbClr val="D8D0C6"/>
-                      </a:solidFill>
-                      <a:prstDash val="solid"/>
-                      <a:round/>
-                      <a:headEnd type="none" w="med" len="med"/>
-                      <a:tailEnd type="none" w="med" len="med"/>
-                    </a:lnT>
-                    <a:lnB w="8890" cap="flat" cmpd="sng" algn="ctr">
-                      <a:solidFill>
-                        <a:srgbClr val="D8D0C6"/>
-                      </a:solidFill>
-                      <a:prstDash val="solid"/>
-                      <a:round/>
-                      <a:headEnd type="none" w="med" len="med"/>
-                      <a:tailEnd type="none" w="med" len="med"/>
-                    </a:lnB>
-                    <a:solidFill>
-                      <a:srgbClr val="FDE8D2"/>
-                    </a:solidFill>
-                  </a:tcPr>
-                </a:tc>
-                <a:tc>
-                  <a:txBody>
-                    <a:bodyPr/>
-                    <a:lstStyle/>
-                    <a:p>
-                      <a:pPr marL="0" indent="0" algn="ctr">
-                        <a:buNone/>
-                      </a:pPr>
-                      <a:r>
-                        <a:rPr lang="en-US" sz="900" dirty="0">
-                          <a:solidFill>
-                            <a:srgbClr val="1E3A5F"/>
-                          </a:solidFill>
-                          <a:latin typeface="Calibri" pitchFamily="34" charset="0"/>
-                          <a:ea typeface="Calibri" pitchFamily="34" charset="-122"/>
-                          <a:cs typeface="Calibri" pitchFamily="34" charset="-120"/>
-                        </a:rPr>
-                        <a:t>35%</a:t>
-                      </a:r>
-                      <a:endParaRPr lang="en-US" sz="900" dirty="0">
-                        <a:latin typeface="Calibri" pitchFamily="34" charset="0"/>
-                        <a:ea typeface="Calibri" pitchFamily="34" charset="0"/>
-                        <a:cs typeface="Calibri" pitchFamily="34" charset="0"/>
-                      </a:endParaRPr>
-                    </a:p>
-                  </a:txBody>
-                  <a:tcPr>
-                    <a:lnL w="8890" cap="flat" cmpd="sng" algn="ctr">
-                      <a:solidFill>
-                        <a:srgbClr val="D8D0C6"/>
-                      </a:solidFill>
-                      <a:prstDash val="solid"/>
-                      <a:round/>
-                      <a:headEnd type="none" w="med" len="med"/>
-                      <a:tailEnd type="none" w="med" len="med"/>
-                    </a:lnL>
-                    <a:lnR w="8890" cap="flat" cmpd="sng" algn="ctr">
-                      <a:solidFill>
-                        <a:srgbClr val="D8D0C6"/>
-                      </a:solidFill>
-                      <a:prstDash val="solid"/>
-                      <a:round/>
-                      <a:headEnd type="none" w="med" len="med"/>
-                      <a:tailEnd type="none" w="med" len="med"/>
-                    </a:lnR>
-                    <a:lnT w="8890" cap="flat" cmpd="sng" algn="ctr">
-                      <a:solidFill>
-                        <a:srgbClr val="D8D0C6"/>
-                      </a:solidFill>
-                      <a:prstDash val="solid"/>
-                      <a:round/>
-                      <a:headEnd type="none" w="med" len="med"/>
-                      <a:tailEnd type="none" w="med" len="med"/>
-                    </a:lnT>
-                    <a:lnB w="8890" cap="flat" cmpd="sng" algn="ctr">
-                      <a:solidFill>
-                        <a:srgbClr val="D8D0C6"/>
-                      </a:solidFill>
-                      <a:prstDash val="solid"/>
-                      <a:round/>
-                      <a:headEnd type="none" w="med" len="med"/>
-                      <a:tailEnd type="none" w="med" len="med"/>
-                    </a:lnB>
-                    <a:solidFill>
-                      <a:srgbClr val="FDE8D2"/>
-                    </a:solidFill>
-                  </a:tcPr>
-                </a:tc>
-                <a:tc>
-                  <a:txBody>
-                    <a:bodyPr/>
-                    <a:lstStyle/>
-                    <a:p>
-                      <a:pPr marL="0" indent="0" algn="ctr">
-                        <a:buNone/>
-                      </a:pPr>
-                      <a:r>
-                        <a:rPr lang="en-US" sz="900" dirty="0">
-                          <a:solidFill>
-                            <a:srgbClr val="1E3A5F"/>
-                          </a:solidFill>
-                          <a:latin typeface="Calibri" pitchFamily="34" charset="0"/>
-                          <a:ea typeface="Calibri" pitchFamily="34" charset="-122"/>
-                          <a:cs typeface="Calibri" pitchFamily="34" charset="-120"/>
-                        </a:rPr>
-                        <a:t>25%</a:t>
-                      </a:r>
-                      <a:endParaRPr lang="en-US" sz="900" dirty="0">
-                        <a:latin typeface="Calibri" pitchFamily="34" charset="0"/>
-                        <a:ea typeface="Calibri" pitchFamily="34" charset="0"/>
-                        <a:cs typeface="Calibri" pitchFamily="34" charset="0"/>
-                      </a:endParaRPr>
-                    </a:p>
-                  </a:txBody>
-                  <a:tcPr>
-                    <a:lnL w="8890" cap="flat" cmpd="sng" algn="ctr">
-                      <a:solidFill>
-                        <a:srgbClr val="D8D0C6"/>
-                      </a:solidFill>
-                      <a:prstDash val="solid"/>
-                      <a:round/>
-                      <a:headEnd type="none" w="med" len="med"/>
-                      <a:tailEnd type="none" w="med" len="med"/>
-                    </a:lnL>
-                    <a:lnR w="8890" cap="flat" cmpd="sng" algn="ctr">
-                      <a:solidFill>
-                        <a:srgbClr val="D8D0C6"/>
-                      </a:solidFill>
-                      <a:prstDash val="solid"/>
-                      <a:round/>
-                      <a:headEnd type="none" w="med" len="med"/>
-                      <a:tailEnd type="none" w="med" len="med"/>
-                    </a:lnR>
-                    <a:lnT w="8890" cap="flat" cmpd="sng" algn="ctr">
-                      <a:solidFill>
-                        <a:srgbClr val="D8D0C6"/>
-                      </a:solidFill>
-                      <a:prstDash val="solid"/>
-                      <a:round/>
-                      <a:headEnd type="none" w="med" len="med"/>
-                      <a:tailEnd type="none" w="med" len="med"/>
-                    </a:lnT>
-                    <a:lnB w="8890" cap="flat" cmpd="sng" algn="ctr">
-                      <a:solidFill>
-                        <a:srgbClr val="D8D0C6"/>
-                      </a:solidFill>
-                      <a:prstDash val="solid"/>
-                      <a:round/>
-                      <a:headEnd type="none" w="med" len="med"/>
-                      <a:tailEnd type="none" w="med" len="med"/>
-                    </a:lnB>
-                    <a:solidFill>
-                      <a:srgbClr val="FDE8D2"/>
-                    </a:solidFill>
-                  </a:tcPr>
-                </a:tc>
-                <a:tc>
-                  <a:txBody>
-                    <a:bodyPr/>
-                    <a:lstStyle/>
-                    <a:p>
-                      <a:pPr marL="0" indent="0" algn="ctr">
-                        <a:buNone/>
-                      </a:pPr>
-                      <a:r>
-                        <a:rPr lang="en-US" sz="900" dirty="0">
-                          <a:solidFill>
-                            <a:srgbClr val="1E3A5F"/>
-                          </a:solidFill>
-                          <a:latin typeface="Calibri" pitchFamily="34" charset="0"/>
-                          <a:ea typeface="Calibri" pitchFamily="34" charset="-122"/>
-                          <a:cs typeface="Calibri" pitchFamily="34" charset="-120"/>
-                        </a:rPr>
-                        <a:t>30%</a:t>
-                      </a:r>
-                      <a:endParaRPr lang="en-US" sz="900" dirty="0">
-                        <a:latin typeface="Calibri" pitchFamily="34" charset="0"/>
-                        <a:ea typeface="Calibri" pitchFamily="34" charset="0"/>
-                        <a:cs typeface="Calibri" pitchFamily="34" charset="0"/>
-                      </a:endParaRPr>
-                    </a:p>
-                  </a:txBody>
-                  <a:tcPr>
-                    <a:lnL w="8890" cap="flat" cmpd="sng" algn="ctr">
-                      <a:solidFill>
-                        <a:srgbClr val="D8D0C6"/>
-                      </a:solidFill>
-                      <a:prstDash val="solid"/>
-                      <a:round/>
-                      <a:headEnd type="none" w="med" len="med"/>
-                      <a:tailEnd type="none" w="med" len="med"/>
-                    </a:lnL>
-                    <a:lnR w="8890" cap="flat" cmpd="sng" algn="ctr">
-                      <a:solidFill>
-                        <a:srgbClr val="D8D0C6"/>
-                      </a:solidFill>
-                      <a:prstDash val="solid"/>
-                      <a:round/>
-                      <a:headEnd type="none" w="med" len="med"/>
-                      <a:tailEnd type="none" w="med" len="med"/>
-                    </a:lnR>
-                    <a:lnT w="8890" cap="flat" cmpd="sng" algn="ctr">
-                      <a:solidFill>
-                        <a:srgbClr val="D8D0C6"/>
-                      </a:solidFill>
-                      <a:prstDash val="solid"/>
-                      <a:round/>
-                      <a:headEnd type="none" w="med" len="med"/>
-                      <a:tailEnd type="none" w="med" len="med"/>
-                    </a:lnT>
-                    <a:lnB w="8890" cap="flat" cmpd="sng" algn="ctr">
-                      <a:solidFill>
-                        <a:srgbClr val="D8D0C6"/>
-                      </a:solidFill>
-                      <a:prstDash val="solid"/>
-                      <a:round/>
-                      <a:headEnd type="none" w="med" len="med"/>
-                      <a:tailEnd type="none" w="med" len="med"/>
-                    </a:lnB>
-                    <a:solidFill>
-                      <a:srgbClr val="FDE8D2"/>
-                    </a:solidFill>
-                  </a:tcPr>
-                </a:tc>
-                <a:tc>
-                  <a:txBody>
-                    <a:bodyPr/>
-                    <a:lstStyle/>
-                    <a:p>
-                      <a:pPr marL="0" indent="0" algn="ctr">
-                        <a:buNone/>
-                      </a:pPr>
-                      <a:r>
-                        <a:rPr lang="en-US" sz="900" dirty="0">
-                          <a:solidFill>
-                            <a:srgbClr val="1E3A5F"/>
-                          </a:solidFill>
-                          <a:latin typeface="Calibri" pitchFamily="34" charset="0"/>
-                          <a:ea typeface="Calibri" pitchFamily="34" charset="-122"/>
-                          <a:cs typeface="Calibri" pitchFamily="34" charset="-120"/>
-                        </a:rPr>
-                        <a:t>10%</a:t>
-                      </a:r>
-                      <a:endParaRPr lang="en-US" sz="900" dirty="0">
-                        <a:latin typeface="Calibri" pitchFamily="34" charset="0"/>
-                        <a:ea typeface="Calibri" pitchFamily="34" charset="0"/>
-                        <a:cs typeface="Calibri" pitchFamily="34" charset="0"/>
-                      </a:endParaRPr>
-                    </a:p>
-                  </a:txBody>
-                  <a:tcPr>
-                    <a:lnL w="8890" cap="flat" cmpd="sng" algn="ctr">
-                      <a:solidFill>
-                        <a:srgbClr val="D8D0C6"/>
-                      </a:solidFill>
-                      <a:prstDash val="solid"/>
-                      <a:round/>
-                      <a:headEnd type="none" w="med" len="med"/>
-                      <a:tailEnd type="none" w="med" len="med"/>
-                    </a:lnL>
-                    <a:lnR w="8890" cap="flat" cmpd="sng" algn="ctr">
-                      <a:solidFill>
-                        <a:srgbClr val="D8D0C6"/>
-                      </a:solidFill>
-                      <a:prstDash val="solid"/>
-                      <a:round/>
-                      <a:headEnd type="none" w="med" len="med"/>
-                      <a:tailEnd type="none" w="med" len="med"/>
-                    </a:lnR>
-                    <a:lnT w="8890" cap="flat" cmpd="sng" algn="ctr">
-                      <a:solidFill>
-                        <a:srgbClr val="D8D0C6"/>
-                      </a:solidFill>
-                      <a:prstDash val="solid"/>
-                      <a:round/>
-                      <a:headEnd type="none" w="med" len="med"/>
-                      <a:tailEnd type="none" w="med" len="med"/>
-                    </a:lnT>
-                    <a:lnB w="8890" cap="flat" cmpd="sng" algn="ctr">
-                      <a:solidFill>
-                        <a:srgbClr val="D8D0C6"/>
-                      </a:solidFill>
-                      <a:prstDash val="solid"/>
-                      <a:round/>
-                      <a:headEnd type="none" w="med" len="med"/>
-                      <a:tailEnd type="none" w="med" len="med"/>
-                    </a:lnB>
-                    <a:solidFill>
-                      <a:srgbClr val="DAEAF5"/>
-                    </a:solidFill>
-                  </a:tcPr>
-                </a:tc>
-                <a:tc>
-                  <a:txBody>
-                    <a:bodyPr/>
-                    <a:lstStyle/>
-                    <a:p>
-                      <a:pPr marL="0" indent="0" algn="ctr">
-                        <a:buNone/>
-                      </a:pPr>
-                      <a:r>
-                        <a:rPr lang="en-US" sz="900" dirty="0">
-                          <a:solidFill>
-                            <a:srgbClr val="1E3A5F"/>
-                          </a:solidFill>
-                          <a:latin typeface="Calibri" pitchFamily="34" charset="0"/>
-                          <a:ea typeface="Calibri" pitchFamily="34" charset="-122"/>
-                          <a:cs typeface="Calibri" pitchFamily="34" charset="-120"/>
-                        </a:rPr>
-                        <a:t>50%</a:t>
-                      </a:r>
-                      <a:endParaRPr lang="en-US" sz="900" dirty="0">
-                        <a:latin typeface="Calibri" pitchFamily="34" charset="0"/>
-                        <a:ea typeface="Calibri" pitchFamily="34" charset="0"/>
-                        <a:cs typeface="Calibri" pitchFamily="34" charset="0"/>
-                      </a:endParaRPr>
-                    </a:p>
-                  </a:txBody>
-                  <a:tcPr>
-                    <a:lnL w="8890" cap="flat" cmpd="sng" algn="ctr">
-                      <a:solidFill>
-                        <a:srgbClr val="D8D0C6"/>
-                      </a:solidFill>
-                      <a:prstDash val="solid"/>
-                      <a:round/>
-                      <a:headEnd type="none" w="med" len="med"/>
-                      <a:tailEnd type="none" w="med" len="med"/>
-                    </a:lnL>
-                    <a:lnR w="8890" cap="flat" cmpd="sng" algn="ctr">
-                      <a:solidFill>
-                        <a:srgbClr val="D8D0C6"/>
-                      </a:solidFill>
-                      <a:prstDash val="solid"/>
-                      <a:round/>
-                      <a:headEnd type="none" w="med" len="med"/>
-                      <a:tailEnd type="none" w="med" len="med"/>
-                    </a:lnR>
-                    <a:lnT w="8890" cap="flat" cmpd="sng" algn="ctr">
-                      <a:solidFill>
-                        <a:srgbClr val="D8D0C6"/>
-                      </a:solidFill>
-                      <a:prstDash val="solid"/>
-                      <a:round/>
-                      <a:headEnd type="none" w="med" len="med"/>
-                      <a:tailEnd type="none" w="med" len="med"/>
-                    </a:lnT>
-                    <a:lnB w="8890" cap="flat" cmpd="sng" algn="ctr">
-                      <a:solidFill>
-                        <a:srgbClr val="D8D0C6"/>
-                      </a:solidFill>
-                      <a:prstDash val="solid"/>
-                      <a:round/>
-                      <a:headEnd type="none" w="med" len="med"/>
-                      <a:tailEnd type="none" w="med" len="med"/>
-                    </a:lnB>
-                    <a:solidFill>
-                      <a:srgbClr val="DAEAF5"/>
-                    </a:solidFill>
-                  </a:tcPr>
-                </a:tc>
-                <a:tc>
-                  <a:txBody>
-                    <a:bodyPr/>
-                    <a:lstStyle/>
-                    <a:p>
-                      <a:pPr marL="0" indent="0" algn="ctr">
-                        <a:buNone/>
-                      </a:pPr>
-                      <a:r>
-                        <a:rPr lang="en-US" sz="900" dirty="0">
-                          <a:solidFill>
-                            <a:srgbClr val="1E3A5F"/>
-                          </a:solidFill>
-                          <a:latin typeface="Calibri" pitchFamily="34" charset="0"/>
-                          <a:ea typeface="Calibri" pitchFamily="34" charset="-122"/>
-                          <a:cs typeface="Calibri" pitchFamily="34" charset="-120"/>
-                        </a:rPr>
-                        <a:t>35%</a:t>
-                      </a:r>
-                      <a:endParaRPr lang="en-US" sz="900" dirty="0">
-                        <a:latin typeface="Calibri" pitchFamily="34" charset="0"/>
-                        <a:ea typeface="Calibri" pitchFamily="34" charset="0"/>
-                        <a:cs typeface="Calibri" pitchFamily="34" charset="0"/>
-                      </a:endParaRPr>
-                    </a:p>
-                  </a:txBody>
-                  <a:tcPr>
-                    <a:lnL w="8890" cap="flat" cmpd="sng" algn="ctr">
-                      <a:solidFill>
-                        <a:srgbClr val="D8D0C6"/>
-                      </a:solidFill>
-                      <a:prstDash val="solid"/>
-                      <a:round/>
-                      <a:headEnd type="none" w="med" len="med"/>
-                      <a:tailEnd type="none" w="med" len="med"/>
-                    </a:lnL>
-                    <a:lnR w="8890" cap="flat" cmpd="sng" algn="ctr">
-                      <a:solidFill>
-                        <a:srgbClr val="D8D0C6"/>
-                      </a:solidFill>
-                      <a:prstDash val="solid"/>
-                      <a:round/>
-                      <a:headEnd type="none" w="med" len="med"/>
-                      <a:tailEnd type="none" w="med" len="med"/>
-                    </a:lnR>
-                    <a:lnT w="8890" cap="flat" cmpd="sng" algn="ctr">
-                      <a:solidFill>
-                        <a:srgbClr val="D8D0C6"/>
-                      </a:solidFill>
-                      <a:prstDash val="solid"/>
-                      <a:round/>
-                      <a:headEnd type="none" w="med" len="med"/>
-                      <a:tailEnd type="none" w="med" len="med"/>
-                    </a:lnT>
-                    <a:lnB w="8890" cap="flat" cmpd="sng" algn="ctr">
-                      <a:solidFill>
-                        <a:srgbClr val="D8D0C6"/>
-                      </a:solidFill>
-                      <a:prstDash val="solid"/>
-                      <a:round/>
-                      <a:headEnd type="none" w="med" len="med"/>
-                      <a:tailEnd type="none" w="med" len="med"/>
-                    </a:lnB>
-                    <a:solidFill>
-                      <a:srgbClr val="DAEAF5"/>
-                    </a:solidFill>
-                  </a:tcPr>
-                </a:tc>
-                <a:tc>
-                  <a:txBody>
-                    <a:bodyPr/>
-                    <a:lstStyle/>
-                    <a:p>
-                      <a:pPr marL="0" indent="0" algn="ctr">
-                        <a:buNone/>
-                      </a:pPr>
-                      <a:r>
-                        <a:rPr lang="en-US" sz="900" dirty="0">
-                          <a:solidFill>
-                            <a:srgbClr val="1E3A5F"/>
-                          </a:solidFill>
-                          <a:latin typeface="Calibri" pitchFamily="34" charset="0"/>
-                          <a:ea typeface="Calibri" pitchFamily="34" charset="-122"/>
-                          <a:cs typeface="Calibri" pitchFamily="34" charset="-120"/>
-                        </a:rPr>
-                        <a:t>5%</a:t>
-                      </a:r>
-                      <a:endParaRPr lang="en-US" sz="900" dirty="0">
-                        <a:latin typeface="Calibri" pitchFamily="34" charset="0"/>
-                        <a:ea typeface="Calibri" pitchFamily="34" charset="0"/>
-                        <a:cs typeface="Calibri" pitchFamily="34" charset="0"/>
-                      </a:endParaRPr>
-                    </a:p>
-                  </a:txBody>
-                  <a:tcPr>
-                    <a:lnL w="8890" cap="flat" cmpd="sng" algn="ctr">
-                      <a:solidFill>
-                        <a:srgbClr val="D8D0C6"/>
-                      </a:solidFill>
-                      <a:prstDash val="solid"/>
-                      <a:round/>
-                      <a:headEnd type="none" w="med" len="med"/>
-                      <a:tailEnd type="none" w="med" len="med"/>
-                    </a:lnL>
-                    <a:lnR w="8890" cap="flat" cmpd="sng" algn="ctr">
-                      <a:solidFill>
-                        <a:srgbClr val="D8D0C6"/>
-                      </a:solidFill>
-                      <a:prstDash val="solid"/>
-                      <a:round/>
-                      <a:headEnd type="none" w="med" len="med"/>
-                      <a:tailEnd type="none" w="med" len="med"/>
-                    </a:lnR>
-                    <a:lnT w="8890" cap="flat" cmpd="sng" algn="ctr">
-                      <a:solidFill>
-                        <a:srgbClr val="D8D0C6"/>
-                      </a:solidFill>
-                      <a:prstDash val="solid"/>
-                      <a:round/>
-                      <a:headEnd type="none" w="med" len="med"/>
-                      <a:tailEnd type="none" w="med" len="med"/>
-                    </a:lnT>
-                    <a:lnB w="8890" cap="flat" cmpd="sng" algn="ctr">
-                      <a:solidFill>
-                        <a:srgbClr val="D8D0C6"/>
-                      </a:solidFill>
-                      <a:prstDash val="solid"/>
-                      <a:round/>
-                      <a:headEnd type="none" w="med" len="med"/>
-                      <a:tailEnd type="none" w="med" len="med"/>
-                    </a:lnB>
-                    <a:solidFill>
-                      <a:srgbClr val="DAEAF5"/>
-                    </a:solidFill>
-                  </a:tcPr>
-                </a:tc>
-              </a:tr>
-              <a:tr h="233172">
-                <a:tc>
-                  <a:txBody>
-                    <a:bodyPr/>
-                    <a:lstStyle/>
-                    <a:p>
-                      <a:pPr marL="0" indent="0" algn="l">
-                        <a:buNone/>
-                      </a:pPr>
-                      <a:r>
-                        <a:rPr lang="en-US" sz="900" dirty="0">
-                          <a:solidFill>
-                            <a:srgbClr val="1E3A5F"/>
-                          </a:solidFill>
-                          <a:latin typeface="Calibri" pitchFamily="34" charset="0"/>
-                          <a:ea typeface="Calibri" pitchFamily="34" charset="-122"/>
-                          <a:cs typeface="Calibri" pitchFamily="34" charset="-120"/>
-                        </a:rPr>
-                        <a:t>C5 激进</a:t>
-                      </a:r>
-                      <a:endParaRPr lang="en-US" sz="900" dirty="0">
-                        <a:latin typeface="Calibri" pitchFamily="34" charset="0"/>
-                        <a:ea typeface="Calibri" pitchFamily="34" charset="0"/>
-                        <a:cs typeface="Calibri" pitchFamily="34" charset="0"/>
-                      </a:endParaRPr>
-                    </a:p>
-                  </a:txBody>
-                  <a:tcPr>
-                    <a:lnL w="8890" cap="flat" cmpd="sng" algn="ctr">
-                      <a:solidFill>
-                        <a:srgbClr val="D8D0C6"/>
-                      </a:solidFill>
-                      <a:prstDash val="solid"/>
-                      <a:round/>
-                      <a:headEnd type="none" w="med" len="med"/>
-                      <a:tailEnd type="none" w="med" len="med"/>
-                    </a:lnL>
-                    <a:lnR w="8890" cap="flat" cmpd="sng" algn="ctr">
-                      <a:solidFill>
-                        <a:srgbClr val="D8D0C6"/>
-                      </a:solidFill>
-                      <a:prstDash val="solid"/>
-                      <a:round/>
-                      <a:headEnd type="none" w="med" len="med"/>
-                      <a:tailEnd type="none" w="med" len="med"/>
-                    </a:lnR>
-                    <a:lnT w="8890" cap="flat" cmpd="sng" algn="ctr">
-                      <a:solidFill>
-                        <a:srgbClr val="D8D0C6"/>
-                      </a:solidFill>
-                      <a:prstDash val="solid"/>
-                      <a:round/>
-                      <a:headEnd type="none" w="med" len="med"/>
-                      <a:tailEnd type="none" w="med" len="med"/>
-                    </a:lnT>
-                    <a:lnB w="8890" cap="flat" cmpd="sng" algn="ctr">
-                      <a:solidFill>
-                        <a:srgbClr val="D8D0C6"/>
-                      </a:solidFill>
-                      <a:prstDash val="solid"/>
-                      <a:round/>
-                      <a:headEnd type="none" w="med" len="med"/>
-                      <a:tailEnd type="none" w="med" len="med"/>
-                    </a:lnB>
-                    <a:solidFill>
-                      <a:srgbClr val="FFFAF4"/>
-                    </a:solidFill>
-                  </a:tcPr>
-                </a:tc>
-                <a:tc>
-                  <a:txBody>
-                    <a:bodyPr/>
-                    <a:lstStyle/>
-                    <a:p>
-                      <a:pPr marL="0" indent="0" algn="l">
-                        <a:buNone/>
-                      </a:pPr>
-                      <a:r>
-                        <a:rPr lang="en-US" sz="900" dirty="0">
-                          <a:solidFill>
-                            <a:srgbClr val="1E3A5F"/>
-                          </a:solidFill>
-                          <a:latin typeface="Calibri" pitchFamily="34" charset="0"/>
-                          <a:ea typeface="Calibri" pitchFamily="34" charset="-122"/>
-                          <a:cs typeface="Calibri" pitchFamily="34" charset="-120"/>
-                        </a:rPr>
-                        <a:t>S1 刚毕业</a:t>
-                      </a:r>
-                      <a:endParaRPr lang="en-US" sz="900" dirty="0">
-                        <a:latin typeface="Calibri" pitchFamily="34" charset="0"/>
-                        <a:ea typeface="Calibri" pitchFamily="34" charset="0"/>
-                        <a:cs typeface="Calibri" pitchFamily="34" charset="0"/>
-                      </a:endParaRPr>
-                    </a:p>
-                  </a:txBody>
-                  <a:tcPr>
-                    <a:lnL w="8890" cap="flat" cmpd="sng" algn="ctr">
-                      <a:solidFill>
-                        <a:srgbClr val="D8D0C6"/>
-                      </a:solidFill>
-                      <a:prstDash val="solid"/>
-                      <a:round/>
-                      <a:headEnd type="none" w="med" len="med"/>
-                      <a:tailEnd type="none" w="med" len="med"/>
-                    </a:lnL>
-                    <a:lnR w="8890" cap="flat" cmpd="sng" algn="ctr">
-                      <a:solidFill>
-                        <a:srgbClr val="D8D0C6"/>
-                      </a:solidFill>
-                      <a:prstDash val="solid"/>
-                      <a:round/>
-                      <a:headEnd type="none" w="med" len="med"/>
-                      <a:tailEnd type="none" w="med" len="med"/>
-                    </a:lnR>
-                    <a:lnT w="8890" cap="flat" cmpd="sng" algn="ctr">
-                      <a:solidFill>
-                        <a:srgbClr val="D8D0C6"/>
-                      </a:solidFill>
-                      <a:prstDash val="solid"/>
-                      <a:round/>
-                      <a:headEnd type="none" w="med" len="med"/>
-                      <a:tailEnd type="none" w="med" len="med"/>
-                    </a:lnT>
-                    <a:lnB w="8890" cap="flat" cmpd="sng" algn="ctr">
-                      <a:solidFill>
-                        <a:srgbClr val="D8D0C6"/>
-                      </a:solidFill>
-                      <a:prstDash val="solid"/>
-                      <a:round/>
-                      <a:headEnd type="none" w="med" len="med"/>
-                      <a:tailEnd type="none" w="med" len="med"/>
-                    </a:lnB>
-                    <a:solidFill>
-                      <a:srgbClr val="FFFAF4"/>
-                    </a:solidFill>
-                  </a:tcPr>
-                </a:tc>
-                <a:tc>
-                  <a:txBody>
-                    <a:bodyPr/>
-                    <a:lstStyle/>
-                    <a:p>
-                      <a:pPr marL="0" indent="0" algn="ctr">
-                        <a:buNone/>
-                      </a:pPr>
-                      <a:r>
-                        <a:rPr lang="en-US" sz="900" dirty="0">
-                          <a:solidFill>
-                            <a:srgbClr val="1E3A5F"/>
-                          </a:solidFill>
-                          <a:latin typeface="Calibri" pitchFamily="34" charset="0"/>
-                          <a:ea typeface="Calibri" pitchFamily="34" charset="-122"/>
-                          <a:cs typeface="Calibri" pitchFamily="34" charset="-120"/>
-                        </a:rPr>
-                        <a:t>5%</a:t>
-                      </a:r>
-                      <a:endParaRPr lang="en-US" sz="900" dirty="0">
-                        <a:latin typeface="Calibri" pitchFamily="34" charset="0"/>
-                        <a:ea typeface="Calibri" pitchFamily="34" charset="0"/>
-                        <a:cs typeface="Calibri" pitchFamily="34" charset="0"/>
-                      </a:endParaRPr>
-                    </a:p>
-                  </a:txBody>
-                  <a:tcPr>
-                    <a:lnL w="8890" cap="flat" cmpd="sng" algn="ctr">
-                      <a:solidFill>
-                        <a:srgbClr val="D8D0C6"/>
-                      </a:solidFill>
-                      <a:prstDash val="solid"/>
-                      <a:round/>
-                      <a:headEnd type="none" w="med" len="med"/>
-                      <a:tailEnd type="none" w="med" len="med"/>
-                    </a:lnL>
-                    <a:lnR w="8890" cap="flat" cmpd="sng" algn="ctr">
-                      <a:solidFill>
-                        <a:srgbClr val="D8D0C6"/>
-                      </a:solidFill>
-                      <a:prstDash val="solid"/>
-                      <a:round/>
-                      <a:headEnd type="none" w="med" len="med"/>
-                      <a:tailEnd type="none" w="med" len="med"/>
-                    </a:lnR>
-                    <a:lnT w="8890" cap="flat" cmpd="sng" algn="ctr">
-                      <a:solidFill>
-                        <a:srgbClr val="D8D0C6"/>
-                      </a:solidFill>
-                      <a:prstDash val="solid"/>
-                      <a:round/>
-                      <a:headEnd type="none" w="med" len="med"/>
-                      <a:tailEnd type="none" w="med" len="med"/>
-                    </a:lnT>
-                    <a:lnB w="8890" cap="flat" cmpd="sng" algn="ctr">
-                      <a:solidFill>
-                        <a:srgbClr val="D8D0C6"/>
-                      </a:solidFill>
-                      <a:prstDash val="solid"/>
-                      <a:round/>
-                      <a:headEnd type="none" w="med" len="med"/>
-                      <a:tailEnd type="none" w="med" len="med"/>
-                    </a:lnB>
-                    <a:solidFill>
-                      <a:srgbClr val="FEF5EC"/>
-                    </a:solidFill>
-                  </a:tcPr>
-                </a:tc>
-                <a:tc>
-                  <a:txBody>
-                    <a:bodyPr/>
-                    <a:lstStyle/>
-                    <a:p>
-                      <a:pPr marL="0" indent="0" algn="ctr">
-                        <a:buNone/>
-                      </a:pPr>
-                      <a:r>
-                        <a:rPr lang="en-US" sz="900" dirty="0">
-                          <a:solidFill>
-                            <a:srgbClr val="1E3A5F"/>
-                          </a:solidFill>
-                          <a:latin typeface="Calibri" pitchFamily="34" charset="0"/>
-                          <a:ea typeface="Calibri" pitchFamily="34" charset="-122"/>
-                          <a:cs typeface="Calibri" pitchFamily="34" charset="-120"/>
-                        </a:rPr>
-                        <a:t>15%</a:t>
-                      </a:r>
-                      <a:endParaRPr lang="en-US" sz="900" dirty="0">
-                        <a:latin typeface="Calibri" pitchFamily="34" charset="0"/>
-                        <a:ea typeface="Calibri" pitchFamily="34" charset="0"/>
-                        <a:cs typeface="Calibri" pitchFamily="34" charset="0"/>
-                      </a:endParaRPr>
-                    </a:p>
-                  </a:txBody>
-                  <a:tcPr>
-                    <a:lnL w="8890" cap="flat" cmpd="sng" algn="ctr">
-                      <a:solidFill>
-                        <a:srgbClr val="D8D0C6"/>
-                      </a:solidFill>
-                      <a:prstDash val="solid"/>
-                      <a:round/>
-                      <a:headEnd type="none" w="med" len="med"/>
-                      <a:tailEnd type="none" w="med" len="med"/>
-                    </a:lnL>
-                    <a:lnR w="8890" cap="flat" cmpd="sng" algn="ctr">
-                      <a:solidFill>
-                        <a:srgbClr val="D8D0C6"/>
-                      </a:solidFill>
-                      <a:prstDash val="solid"/>
-                      <a:round/>
-                      <a:headEnd type="none" w="med" len="med"/>
-                      <a:tailEnd type="none" w="med" len="med"/>
-                    </a:lnR>
-                    <a:lnT w="8890" cap="flat" cmpd="sng" algn="ctr">
-                      <a:solidFill>
-                        <a:srgbClr val="D8D0C6"/>
-                      </a:solidFill>
-                      <a:prstDash val="solid"/>
-                      <a:round/>
-                      <a:headEnd type="none" w="med" len="med"/>
-                      <a:tailEnd type="none" w="med" len="med"/>
-                    </a:lnT>
-                    <a:lnB w="8890" cap="flat" cmpd="sng" algn="ctr">
-                      <a:solidFill>
-                        <a:srgbClr val="D8D0C6"/>
-                      </a:solidFill>
-                      <a:prstDash val="solid"/>
-                      <a:round/>
-                      <a:headEnd type="none" w="med" len="med"/>
-                      <a:tailEnd type="none" w="med" len="med"/>
-                    </a:lnB>
-                    <a:solidFill>
-                      <a:srgbClr val="FEF5EC"/>
-                    </a:solidFill>
-                  </a:tcPr>
-                </a:tc>
-                <a:tc>
-                  <a:txBody>
-                    <a:bodyPr/>
-                    <a:lstStyle/>
-                    <a:p>
-                      <a:pPr marL="0" indent="0" algn="ctr">
-                        <a:buNone/>
-                      </a:pPr>
-                      <a:r>
-                        <a:rPr lang="en-US" sz="900" dirty="0">
-                          <a:solidFill>
-                            <a:srgbClr val="1E3A5F"/>
-                          </a:solidFill>
-                          <a:latin typeface="Calibri" pitchFamily="34" charset="0"/>
-                          <a:ea typeface="Calibri" pitchFamily="34" charset="-122"/>
-                          <a:cs typeface="Calibri" pitchFamily="34" charset="-120"/>
-                        </a:rPr>
-                        <a:t>45%</a:t>
-                      </a:r>
-                      <a:endParaRPr lang="en-US" sz="900" dirty="0">
-                        <a:latin typeface="Calibri" pitchFamily="34" charset="0"/>
-                        <a:ea typeface="Calibri" pitchFamily="34" charset="0"/>
-                        <a:cs typeface="Calibri" pitchFamily="34" charset="0"/>
-                      </a:endParaRPr>
-                    </a:p>
-                  </a:txBody>
-                  <a:tcPr>
-                    <a:lnL w="8890" cap="flat" cmpd="sng" algn="ctr">
-                      <a:solidFill>
-                        <a:srgbClr val="D8D0C6"/>
-                      </a:solidFill>
-                      <a:prstDash val="solid"/>
-                      <a:round/>
-                      <a:headEnd type="none" w="med" len="med"/>
-                      <a:tailEnd type="none" w="med" len="med"/>
-                    </a:lnL>
-                    <a:lnR w="8890" cap="flat" cmpd="sng" algn="ctr">
-                      <a:solidFill>
-                        <a:srgbClr val="D8D0C6"/>
-                      </a:solidFill>
-                      <a:prstDash val="solid"/>
-                      <a:round/>
-                      <a:headEnd type="none" w="med" len="med"/>
-                      <a:tailEnd type="none" w="med" len="med"/>
-                    </a:lnR>
-                    <a:lnT w="8890" cap="flat" cmpd="sng" algn="ctr">
-                      <a:solidFill>
-                        <a:srgbClr val="D8D0C6"/>
-                      </a:solidFill>
-                      <a:prstDash val="solid"/>
-                      <a:round/>
-                      <a:headEnd type="none" w="med" len="med"/>
-                      <a:tailEnd type="none" w="med" len="med"/>
-                    </a:lnT>
-                    <a:lnB w="8890" cap="flat" cmpd="sng" algn="ctr">
-                      <a:solidFill>
-                        <a:srgbClr val="D8D0C6"/>
-                      </a:solidFill>
-                      <a:prstDash val="solid"/>
-                      <a:round/>
-                      <a:headEnd type="none" w="med" len="med"/>
-                      <a:tailEnd type="none" w="med" len="med"/>
-                    </a:lnB>
-                    <a:solidFill>
-                      <a:srgbClr val="FEF5EC"/>
-                    </a:solidFill>
-                  </a:tcPr>
-                </a:tc>
-                <a:tc>
-                  <a:txBody>
-                    <a:bodyPr/>
-                    <a:lstStyle/>
-                    <a:p>
-                      <a:pPr marL="0" indent="0" algn="ctr">
-                        <a:buNone/>
-                      </a:pPr>
-                      <a:r>
-                        <a:rPr lang="en-US" sz="900" dirty="0">
-                          <a:solidFill>
-                            <a:srgbClr val="1E3A5F"/>
-                          </a:solidFill>
-                          <a:latin typeface="Calibri" pitchFamily="34" charset="0"/>
-                          <a:ea typeface="Calibri" pitchFamily="34" charset="-122"/>
-                          <a:cs typeface="Calibri" pitchFamily="34" charset="-120"/>
-                        </a:rPr>
-                        <a:t>35%</a:t>
-                      </a:r>
-                      <a:endParaRPr lang="en-US" sz="900" dirty="0">
-                        <a:latin typeface="Calibri" pitchFamily="34" charset="0"/>
-                        <a:ea typeface="Calibri" pitchFamily="34" charset="0"/>
-                        <a:cs typeface="Calibri" pitchFamily="34" charset="0"/>
-                      </a:endParaRPr>
-                    </a:p>
-                  </a:txBody>
-                  <a:tcPr>
-                    <a:lnL w="8890" cap="flat" cmpd="sng" algn="ctr">
-                      <a:solidFill>
-                        <a:srgbClr val="D8D0C6"/>
-                      </a:solidFill>
-                      <a:prstDash val="solid"/>
-                      <a:round/>
-                      <a:headEnd type="none" w="med" len="med"/>
-                      <a:tailEnd type="none" w="med" len="med"/>
-                    </a:lnL>
-                    <a:lnR w="8890" cap="flat" cmpd="sng" algn="ctr">
-                      <a:solidFill>
-                        <a:srgbClr val="D8D0C6"/>
-                      </a:solidFill>
-                      <a:prstDash val="solid"/>
-                      <a:round/>
-                      <a:headEnd type="none" w="med" len="med"/>
-                      <a:tailEnd type="none" w="med" len="med"/>
-                    </a:lnR>
-                    <a:lnT w="8890" cap="flat" cmpd="sng" algn="ctr">
-                      <a:solidFill>
-                        <a:srgbClr val="D8D0C6"/>
-                      </a:solidFill>
-                      <a:prstDash val="solid"/>
-                      <a:round/>
-                      <a:headEnd type="none" w="med" len="med"/>
-                      <a:tailEnd type="none" w="med" len="med"/>
-                    </a:lnT>
-                    <a:lnB w="8890" cap="flat" cmpd="sng" algn="ctr">
-                      <a:solidFill>
-                        <a:srgbClr val="D8D0C6"/>
-                      </a:solidFill>
-                      <a:prstDash val="solid"/>
-                      <a:round/>
-                      <a:headEnd type="none" w="med" len="med"/>
-                      <a:tailEnd type="none" w="med" len="med"/>
-                    </a:lnB>
-                    <a:solidFill>
-                      <a:srgbClr val="FEF5EC"/>
-                    </a:solidFill>
-                  </a:tcPr>
-                </a:tc>
-                <a:tc>
-                  <a:txBody>
-                    <a:bodyPr/>
-                    <a:lstStyle/>
-                    <a:p>
-                      <a:pPr marL="0" indent="0" algn="ctr">
-                        <a:buNone/>
-                      </a:pPr>
-                      <a:r>
-                        <a:rPr lang="en-US" sz="900" dirty="0">
-                          <a:solidFill>
-                            <a:srgbClr val="1E3A5F"/>
-                          </a:solidFill>
-                          <a:latin typeface="Calibri" pitchFamily="34" charset="0"/>
-                          <a:ea typeface="Calibri" pitchFamily="34" charset="-122"/>
-                          <a:cs typeface="Calibri" pitchFamily="34" charset="-120"/>
-                        </a:rPr>
-                        <a:t>5%</a:t>
-                      </a:r>
-                      <a:endParaRPr lang="en-US" sz="900" dirty="0">
-                        <a:latin typeface="Calibri" pitchFamily="34" charset="0"/>
-                        <a:ea typeface="Calibri" pitchFamily="34" charset="0"/>
-                        <a:cs typeface="Calibri" pitchFamily="34" charset="0"/>
-                      </a:endParaRPr>
-                    </a:p>
-                  </a:txBody>
-                  <a:tcPr>
-                    <a:lnL w="8890" cap="flat" cmpd="sng" algn="ctr">
-                      <a:solidFill>
-                        <a:srgbClr val="D8D0C6"/>
-                      </a:solidFill>
-                      <a:prstDash val="solid"/>
-                      <a:round/>
-                      <a:headEnd type="none" w="med" len="med"/>
-                      <a:tailEnd type="none" w="med" len="med"/>
-                    </a:lnL>
-                    <a:lnR w="8890" cap="flat" cmpd="sng" algn="ctr">
-                      <a:solidFill>
-                        <a:srgbClr val="D8D0C6"/>
-                      </a:solidFill>
-                      <a:prstDash val="solid"/>
-                      <a:round/>
-                      <a:headEnd type="none" w="med" len="med"/>
-                      <a:tailEnd type="none" w="med" len="med"/>
-                    </a:lnR>
-                    <a:lnT w="8890" cap="flat" cmpd="sng" algn="ctr">
-                      <a:solidFill>
-                        <a:srgbClr val="D8D0C6"/>
-                      </a:solidFill>
-                      <a:prstDash val="solid"/>
-                      <a:round/>
-                      <a:headEnd type="none" w="med" len="med"/>
-                      <a:tailEnd type="none" w="med" len="med"/>
-                    </a:lnT>
-                    <a:lnB w="8890" cap="flat" cmpd="sng" algn="ctr">
-                      <a:solidFill>
-                        <a:srgbClr val="D8D0C6"/>
-                      </a:solidFill>
-                      <a:prstDash val="solid"/>
-                      <a:round/>
-                      <a:headEnd type="none" w="med" len="med"/>
-                      <a:tailEnd type="none" w="med" len="med"/>
-                    </a:lnB>
-                    <a:solidFill>
-                      <a:srgbClr val="EDF2F8"/>
-                    </a:solidFill>
-                  </a:tcPr>
-                </a:tc>
-                <a:tc>
-                  <a:txBody>
-                    <a:bodyPr/>
-                    <a:lstStyle/>
-                    <a:p>
-                      <a:pPr marL="0" indent="0" algn="ctr">
-                        <a:buNone/>
-                      </a:pPr>
-                      <a:r>
-                        <a:rPr lang="en-US" sz="900" dirty="0">
-                          <a:solidFill>
-                            <a:srgbClr val="1E3A5F"/>
-                          </a:solidFill>
-                          <a:latin typeface="Calibri" pitchFamily="34" charset="0"/>
-                          <a:ea typeface="Calibri" pitchFamily="34" charset="-122"/>
-                          <a:cs typeface="Calibri" pitchFamily="34" charset="-120"/>
-                        </a:rPr>
-                        <a:t>20%</a:t>
-                      </a:r>
-                      <a:endParaRPr lang="en-US" sz="900" dirty="0">
-                        <a:latin typeface="Calibri" pitchFamily="34" charset="0"/>
-                        <a:ea typeface="Calibri" pitchFamily="34" charset="0"/>
-                        <a:cs typeface="Calibri" pitchFamily="34" charset="0"/>
-                      </a:endParaRPr>
-                    </a:p>
-                  </a:txBody>
-                  <a:tcPr>
-                    <a:lnL w="8890" cap="flat" cmpd="sng" algn="ctr">
-                      <a:solidFill>
-                        <a:srgbClr val="D8D0C6"/>
-                      </a:solidFill>
-                      <a:prstDash val="solid"/>
-                      <a:round/>
-                      <a:headEnd type="none" w="med" len="med"/>
-                      <a:tailEnd type="none" w="med" len="med"/>
-                    </a:lnL>
-                    <a:lnR w="8890" cap="flat" cmpd="sng" algn="ctr">
-                      <a:solidFill>
-                        <a:srgbClr val="D8D0C6"/>
-                      </a:solidFill>
-                      <a:prstDash val="solid"/>
-                      <a:round/>
-                      <a:headEnd type="none" w="med" len="med"/>
-                      <a:tailEnd type="none" w="med" len="med"/>
-                    </a:lnR>
-                    <a:lnT w="8890" cap="flat" cmpd="sng" algn="ctr">
-                      <a:solidFill>
-                        <a:srgbClr val="D8D0C6"/>
-                      </a:solidFill>
-                      <a:prstDash val="solid"/>
-                      <a:round/>
-                      <a:headEnd type="none" w="med" len="med"/>
-                      <a:tailEnd type="none" w="med" len="med"/>
-                    </a:lnT>
-                    <a:lnB w="8890" cap="flat" cmpd="sng" algn="ctr">
-                      <a:solidFill>
-                        <a:srgbClr val="D8D0C6"/>
-                      </a:solidFill>
-                      <a:prstDash val="solid"/>
-                      <a:round/>
-                      <a:headEnd type="none" w="med" len="med"/>
-                      <a:tailEnd type="none" w="med" len="med"/>
-                    </a:lnB>
-                    <a:solidFill>
-                      <a:srgbClr val="EDF2F8"/>
-                    </a:solidFill>
-                  </a:tcPr>
-                </a:tc>
-                <a:tc>
-                  <a:txBody>
-                    <a:bodyPr/>
-                    <a:lstStyle/>
-                    <a:p>
-                      <a:pPr marL="0" indent="0" algn="ctr">
-                        <a:buNone/>
-                      </a:pPr>
-                      <a:r>
-                        <a:rPr lang="en-US" sz="900" dirty="0">
-                          <a:solidFill>
-                            <a:srgbClr val="1E3A5F"/>
-                          </a:solidFill>
-                          <a:latin typeface="Calibri" pitchFamily="34" charset="0"/>
-                          <a:ea typeface="Calibri" pitchFamily="34" charset="-122"/>
-                          <a:cs typeface="Calibri" pitchFamily="34" charset="-120"/>
-                        </a:rPr>
-                        <a:t>55%</a:t>
-                      </a:r>
-                      <a:endParaRPr lang="en-US" sz="900" dirty="0">
-                        <a:latin typeface="Calibri" pitchFamily="34" charset="0"/>
-                        <a:ea typeface="Calibri" pitchFamily="34" charset="0"/>
-                        <a:cs typeface="Calibri" pitchFamily="34" charset="0"/>
-                      </a:endParaRPr>
-                    </a:p>
-                  </a:txBody>
-                  <a:tcPr>
-                    <a:lnL w="8890" cap="flat" cmpd="sng" algn="ctr">
-                      <a:solidFill>
-                        <a:srgbClr val="D8D0C6"/>
-                      </a:solidFill>
-                      <a:prstDash val="solid"/>
-                      <a:round/>
-                      <a:headEnd type="none" w="med" len="med"/>
-                      <a:tailEnd type="none" w="med" len="med"/>
-                    </a:lnL>
-                    <a:lnR w="8890" cap="flat" cmpd="sng" algn="ctr">
-                      <a:solidFill>
-                        <a:srgbClr val="D8D0C6"/>
-                      </a:solidFill>
-                      <a:prstDash val="solid"/>
-                      <a:round/>
-                      <a:headEnd type="none" w="med" len="med"/>
-                      <a:tailEnd type="none" w="med" len="med"/>
-                    </a:lnR>
-                    <a:lnT w="8890" cap="flat" cmpd="sng" algn="ctr">
-                      <a:solidFill>
-                        <a:srgbClr val="D8D0C6"/>
-                      </a:solidFill>
-                      <a:prstDash val="solid"/>
-                      <a:round/>
-                      <a:headEnd type="none" w="med" len="med"/>
-                      <a:tailEnd type="none" w="med" len="med"/>
-                    </a:lnT>
-                    <a:lnB w="8890" cap="flat" cmpd="sng" algn="ctr">
-                      <a:solidFill>
-                        <a:srgbClr val="D8D0C6"/>
-                      </a:solidFill>
-                      <a:prstDash val="solid"/>
-                      <a:round/>
-                      <a:headEnd type="none" w="med" len="med"/>
-                      <a:tailEnd type="none" w="med" len="med"/>
-                    </a:lnB>
-                    <a:solidFill>
-                      <a:srgbClr val="EDF2F8"/>
-                    </a:solidFill>
-                  </a:tcPr>
-                </a:tc>
-                <a:tc>
-                  <a:txBody>
-                    <a:bodyPr/>
-                    <a:lstStyle/>
-                    <a:p>
-                      <a:pPr marL="0" indent="0" algn="ctr">
-                        <a:buNone/>
-                      </a:pPr>
-                      <a:r>
-                        <a:rPr lang="en-US" sz="900" dirty="0">
-                          <a:solidFill>
-                            <a:srgbClr val="1E3A5F"/>
-                          </a:solidFill>
-                          <a:latin typeface="Calibri" pitchFamily="34" charset="0"/>
-                          <a:ea typeface="Calibri" pitchFamily="34" charset="-122"/>
-                          <a:cs typeface="Calibri" pitchFamily="34" charset="-120"/>
-                        </a:rPr>
-                        <a:t>20%</a:t>
-                      </a:r>
-                      <a:endParaRPr lang="en-US" sz="900" dirty="0">
-                        <a:latin typeface="Calibri" pitchFamily="34" charset="0"/>
-                        <a:ea typeface="Calibri" pitchFamily="34" charset="0"/>
-                        <a:cs typeface="Calibri" pitchFamily="34" charset="0"/>
-                      </a:endParaRPr>
-                    </a:p>
-                  </a:txBody>
-                  <a:tcPr>
-                    <a:lnL w="8890" cap="flat" cmpd="sng" algn="ctr">
-                      <a:solidFill>
-                        <a:srgbClr val="D8D0C6"/>
-                      </a:solidFill>
-                      <a:prstDash val="solid"/>
-                      <a:round/>
-                      <a:headEnd type="none" w="med" len="med"/>
-                      <a:tailEnd type="none" w="med" len="med"/>
-                    </a:lnL>
-                    <a:lnR w="8890" cap="flat" cmpd="sng" algn="ctr">
-                      <a:solidFill>
-                        <a:srgbClr val="D8D0C6"/>
-                      </a:solidFill>
-                      <a:prstDash val="solid"/>
-                      <a:round/>
-                      <a:headEnd type="none" w="med" len="med"/>
-                      <a:tailEnd type="none" w="med" len="med"/>
-                    </a:lnR>
-                    <a:lnT w="8890" cap="flat" cmpd="sng" algn="ctr">
-                      <a:solidFill>
-                        <a:srgbClr val="D8D0C6"/>
-                      </a:solidFill>
-                      <a:prstDash val="solid"/>
-                      <a:round/>
-                      <a:headEnd type="none" w="med" len="med"/>
-                      <a:tailEnd type="none" w="med" len="med"/>
-                    </a:lnT>
-                    <a:lnB w="8890" cap="flat" cmpd="sng" algn="ctr">
-                      <a:solidFill>
-                        <a:srgbClr val="D8D0C6"/>
-                      </a:solidFill>
-                      <a:prstDash val="solid"/>
-                      <a:round/>
-                      <a:headEnd type="none" w="med" len="med"/>
-                      <a:tailEnd type="none" w="med" len="med"/>
-                    </a:lnB>
-                    <a:solidFill>
-                      <a:srgbClr val="EDF2F8"/>
-                    </a:solidFill>
-                  </a:tcPr>
-                </a:tc>
-              </a:tr>
-            </a:tbl>
-          </a:graphicData>
-        </a:graphic>
-      </p:graphicFrame>
-      <p:pic>
-        <p:nvPicPr>
-          <p:cNvPr id="20" name="Image 0" descr="preencoded.png"/>
-          <p:cNvPicPr>
-            <a:picLocks noChangeAspect="1"/>
-          </p:cNvPicPr>
-          <p:nvPr/>
-        </p:nvPicPr>
-        <p:blipFill>
-          <a:blip r:embed="rId1"/>
-          <a:stretch>
-            <a:fillRect/>
-          </a:stretch>
-        </p:blipFill>
-        <p:spPr>
-          <a:xfrm>
-            <a:off x="320040" y="3007995"/>
-            <a:ext cx="6516370" cy="2100580"/>
-          </a:xfrm>
-          <a:prstGeom prst="rect">
-            <a:avLst/>
-          </a:prstGeom>
-        </p:spPr>
-      </p:pic>
       <p:sp>
         <p:nvSpPr>
           <p:cNvPr id="22" name="Text 18"/>
@@ -14241,8 +10893,8 @@
         </p:nvSpPr>
         <p:spPr>
           <a:xfrm>
-            <a:off x="7004050" y="2176145"/>
-            <a:ext cx="1938655" cy="1882775"/>
+            <a:off x="7004050" y="2004695"/>
+            <a:ext cx="1938655" cy="549275"/>
           </a:xfrm>
           <a:prstGeom prst="rect">
             <a:avLst/>
@@ -14256,94 +10908,6 @@
             <a:pPr marL="0" indent="0">
               <a:buNone/>
             </a:pPr>
-            <a:r>
-              <a:rPr lang="zh-CN" altLang="en-US" sz="900" dirty="0">
-                <a:solidFill>
-                  <a:srgbClr val="1E3A5F"/>
-                </a:solidFill>
-                <a:latin typeface="Calibri" pitchFamily="34" charset="0"/>
-                <a:ea typeface="Calibri" pitchFamily="34" charset="-122"/>
-                <a:cs typeface="Calibri" pitchFamily="34" charset="-120"/>
-              </a:rPr>
-              <a:t>一</a:t>
-            </a:r>
-            <a:r>
-              <a:rPr lang="en-US" altLang="zh-CN" sz="900" dirty="0">
-                <a:solidFill>
-                  <a:srgbClr val="1E3A5F"/>
-                </a:solidFill>
-                <a:latin typeface="Calibri" pitchFamily="34" charset="0"/>
-                <a:ea typeface="Calibri" pitchFamily="34" charset="-122"/>
-                <a:cs typeface="Calibri" pitchFamily="34" charset="-120"/>
-              </a:rPr>
-              <a:t>、</a:t>
-            </a:r>
-            <a:r>
-              <a:rPr lang="en-US" sz="900" dirty="0">
-                <a:solidFill>
-                  <a:srgbClr val="1E3A5F"/>
-                </a:solidFill>
-                <a:latin typeface="Calibri" pitchFamily="34" charset="0"/>
-                <a:ea typeface="Calibri" pitchFamily="34" charset="-122"/>
-                <a:cs typeface="Calibri" pitchFamily="34" charset="-120"/>
-              </a:rPr>
-              <a:t>3.0 权重随生命周期变化更连续，420 更接近规则模板</a:t>
-            </a:r>
-            <a:endParaRPr lang="en-US" sz="900" dirty="0">
-              <a:solidFill>
-                <a:srgbClr val="1E3A5F"/>
-              </a:solidFill>
-              <a:latin typeface="Calibri" pitchFamily="34" charset="0"/>
-              <a:ea typeface="Calibri" pitchFamily="34" charset="-122"/>
-              <a:cs typeface="Calibri" pitchFamily="34" charset="-120"/>
-            </a:endParaRPr>
-          </a:p>
-          <a:p>
-            <a:pPr marL="0" indent="0">
-              <a:buNone/>
-            </a:pPr>
-            <a:endParaRPr lang="en-US" sz="900" dirty="0"/>
-          </a:p>
-          <a:p>
-            <a:pPr marL="0" indent="0">
-              <a:buNone/>
-            </a:pPr>
-            <a:r>
-              <a:rPr lang="zh-CN" altLang="en-US" sz="900" dirty="0">
-                <a:solidFill>
-                  <a:srgbClr val="1E3A5F"/>
-                </a:solidFill>
-                <a:latin typeface="Calibri" pitchFamily="34" charset="0"/>
-                <a:ea typeface="Calibri" pitchFamily="34" charset="-122"/>
-                <a:cs typeface="Calibri" pitchFamily="34" charset="-120"/>
-                <a:sym typeface="+mn-ea"/>
-              </a:rPr>
-              <a:t>二</a:t>
-            </a:r>
-            <a:r>
-              <a:rPr lang="en-US" altLang="zh-CN" sz="900" dirty="0">
-                <a:solidFill>
-                  <a:srgbClr val="1E3A5F"/>
-                </a:solidFill>
-                <a:latin typeface="Calibri" pitchFamily="34" charset="0"/>
-                <a:ea typeface="Calibri" pitchFamily="34" charset="-122"/>
-                <a:cs typeface="Calibri" pitchFamily="34" charset="-120"/>
-                <a:sym typeface="+mn-ea"/>
-              </a:rPr>
-              <a:t>、</a:t>
-            </a:r>
-            <a:r>
-              <a:rPr lang="en-US" sz="900" dirty="0">
-                <a:solidFill>
-                  <a:srgbClr val="1E3A5F"/>
-                </a:solidFill>
-                <a:latin typeface="Calibri" pitchFamily="34" charset="0"/>
-                <a:ea typeface="Calibri" pitchFamily="34" charset="-122"/>
-                <a:cs typeface="Calibri" pitchFamily="34" charset="-120"/>
-                <a:sym typeface="+mn-ea"/>
-              </a:rPr>
-              <a:t>3.0 在中高风险画像中更有效使用另类资产做分散，420 的 ALT 权重普遍偏低</a:t>
-            </a:r>
             <a:endParaRPr lang="en-US" sz="900" dirty="0">
               <a:solidFill>
                 <a:srgbClr val="1E3A5F"/>
@@ -14353,110 +10917,6 @@
               <a:cs typeface="Calibri" pitchFamily="34" charset="-120"/>
               <a:sym typeface="+mn-ea"/>
             </a:endParaRPr>
-          </a:p>
-          <a:p>
-            <a:pPr marL="0" indent="0">
-              <a:buNone/>
-            </a:pPr>
-            <a:endParaRPr lang="en-US" sz="900" dirty="0">
-              <a:solidFill>
-                <a:srgbClr val="1E3A5F"/>
-              </a:solidFill>
-              <a:latin typeface="Calibri" pitchFamily="34" charset="0"/>
-              <a:ea typeface="Calibri" pitchFamily="34" charset="-122"/>
-              <a:cs typeface="Calibri" pitchFamily="34" charset="-120"/>
-              <a:sym typeface="+mn-ea"/>
-            </a:endParaRPr>
-          </a:p>
-          <a:p>
-            <a:pPr marL="0" indent="0">
-              <a:buNone/>
-            </a:pPr>
-            <a:r>
-              <a:rPr lang="zh-CN" altLang="en-US" sz="900" dirty="0">
-                <a:solidFill>
-                  <a:srgbClr val="1E3A5F"/>
-                </a:solidFill>
-                <a:latin typeface="Calibri" pitchFamily="34" charset="0"/>
-                <a:ea typeface="Calibri" pitchFamily="34" charset="-122"/>
-                <a:cs typeface="Calibri" pitchFamily="34" charset="-120"/>
-                <a:sym typeface="+mn-ea"/>
-              </a:rPr>
-              <a:t>三</a:t>
-            </a:r>
-            <a:r>
-              <a:rPr lang="en-US" altLang="zh-CN" sz="900" dirty="0">
-                <a:solidFill>
-                  <a:srgbClr val="1E3A5F"/>
-                </a:solidFill>
-                <a:latin typeface="Calibri" pitchFamily="34" charset="0"/>
-                <a:ea typeface="Calibri" pitchFamily="34" charset="-122"/>
-                <a:cs typeface="Calibri" pitchFamily="34" charset="-120"/>
-                <a:sym typeface="+mn-ea"/>
-              </a:rPr>
-              <a:t>、</a:t>
-            </a:r>
-            <a:r>
-              <a:rPr lang="en-US" sz="900" dirty="0">
-                <a:solidFill>
-                  <a:srgbClr val="1E3A5F"/>
-                </a:solidFill>
-                <a:latin typeface="Calibri" pitchFamily="34" charset="0"/>
-                <a:ea typeface="Calibri" pitchFamily="34" charset="-122"/>
-                <a:cs typeface="Calibri" pitchFamily="34" charset="-120"/>
-                <a:sym typeface="+mn-ea"/>
-              </a:rPr>
-              <a:t>3.0 的核心不是“更激进”，而是在风险预算内重组风险暴露结构</a:t>
-            </a:r>
-            <a:endParaRPr lang="en-US" sz="900" dirty="0"/>
-          </a:p>
-          <a:p>
-            <a:pPr marL="0" indent="0">
-              <a:buNone/>
-            </a:pPr>
-            <a:endParaRPr lang="en-US" sz="900" dirty="0"/>
-          </a:p>
-          <a:p>
-            <a:pPr marL="0" indent="0">
-              <a:buNone/>
-            </a:pPr>
-            <a:r>
-              <a:rPr lang="zh-CN" altLang="en-US" sz="900" dirty="0">
-                <a:solidFill>
-                  <a:srgbClr val="1E3A5F"/>
-                </a:solidFill>
-                <a:latin typeface="Calibri" pitchFamily="34" charset="0"/>
-                <a:ea typeface="Calibri" pitchFamily="34" charset="-122"/>
-                <a:cs typeface="Calibri" pitchFamily="34" charset="-120"/>
-                <a:sym typeface="+mn-ea"/>
-              </a:rPr>
-              <a:t>四</a:t>
-            </a:r>
-            <a:r>
-              <a:rPr lang="en-US" altLang="zh-CN" sz="900" dirty="0">
-                <a:solidFill>
-                  <a:srgbClr val="1E3A5F"/>
-                </a:solidFill>
-                <a:latin typeface="Calibri" pitchFamily="34" charset="0"/>
-                <a:ea typeface="Calibri" pitchFamily="34" charset="-122"/>
-                <a:cs typeface="Calibri" pitchFamily="34" charset="-120"/>
-                <a:sym typeface="+mn-ea"/>
-              </a:rPr>
-              <a:t>、4</a:t>
-            </a:r>
-            <a:r>
-              <a:rPr lang="en-US" sz="900" dirty="0">
-                <a:solidFill>
-                  <a:srgbClr val="1E3A5F"/>
-                </a:solidFill>
-                <a:latin typeface="Calibri" pitchFamily="34" charset="0"/>
-                <a:ea typeface="Calibri" pitchFamily="34" charset="-122"/>
-                <a:cs typeface="Calibri" pitchFamily="34" charset="-120"/>
-                <a:sym typeface="+mn-ea"/>
-              </a:rPr>
-              <a:t>20 的优势在于规则透明、易于审计与复现</a:t>
-            </a:r>
-            <a:endParaRPr lang="en-US" sz="900" dirty="0"/>
           </a:p>
           <a:p>
             <a:pPr marL="0" indent="0">

</xml_diff>